<commit_message>
Correct stale LangGraph claims; drop the dead langgraph/langchain deps
The shipped Coordinator is a plain Python state machine (run_coordinator.py),
but several docs still described the swarm as running on LangGraph. Corrected
the claims across METHODOLOGY, AGENT_DESIGN, REPORT_PRELIM, and the slide
source, and amended D3 in SPEC rather than deleting it so the original
reasoning and the deviation both survive. Kept the "we rejected LangGraph"
record in CLAUDE.md, PROJECT_LOG, and the run_coordinator.py header, plus the
related-work citations.

No Python file imports langgraph or langchain, so removed all three
(langgraph, langchain-anthropic, langchain-community) from pyproject. The LLM
interface imports the anthropic SDK directly and only had it transitively via
langchain-anthropic, so promoted anthropic>=0.87 to a direct dependency and
re-locked. 335 tests pass.

Co-Authored-By: Claude Opus 4.8 <noreply@anthropic.com>
</commit_message>
<xml_diff>
--- a/docs/PROGRESS_SLIDES_2026-06-02.pptx
+++ b/docs/PROGRESS_SLIDES_2026-06-02.pptx
@@ -3626,7 +3626,7 @@
                 </a:solidFill>
                 <a:latin typeface="Calibri"/>
               </a:rPr>
-              <a:t>149</a:t>
+              <a:t>164</a:t>
             </a:r>
           </a:p>
         </p:txBody>
@@ -3661,7 +3661,7 @@
                 </a:solidFill>
                 <a:latin typeface="Calibri"/>
               </a:rPr>
-              <a:t>290 Researcher · 287 Verifier · 34 Adjudicator.</a:t>
+              <a:t>307 Researcher · 304 Verifier · 34 Adjudicator.</a:t>
             </a:r>
           </a:p>
         </p:txBody>
@@ -4012,7 +4012,7 @@
                 </a:solidFill>
                 <a:latin typeface="Calibri"/>
               </a:rPr>
-              <a:t>68%</a:t>
+              <a:t>63%</a:t>
             </a:r>
           </a:p>
         </p:txBody>
@@ -4047,7 +4047,7 @@
                 </a:solidFill>
                 <a:latin typeface="Calibri"/>
               </a:rPr>
-              <a:t>101 / 149 match against ODMI 2025.</a:t>
+              <a:t>103 / 164 match against ODMI 2025.</a:t>
             </a:r>
           </a:p>
         </p:txBody>
@@ -4205,7 +4205,7 @@
                 </a:solidFill>
                 <a:latin typeface="Calibri"/>
               </a:rPr>
-              <a:t>£31.00</a:t>
+              <a:t>£42.29</a:t>
             </a:r>
           </a:p>
         </p:txBody>
@@ -4398,7 +4398,7 @@
                 </a:solidFill>
                 <a:latin typeface="Calibri"/>
               </a:rPr>
-              <a:t>Researcher proposes, Verifier tries to disprove, Adjudicator steps in when retries are exhausted. Average runtime ~120s.</a:t>
+              <a:t>Researcher proposes, Verifier tries to disprove, Adjudicator steps in when retries are exhausted. Average runtime ~113s.</a:t>
             </a:r>
           </a:p>
         </p:txBody>
@@ -6912,7 +6912,7 @@
         </p:nvSpPr>
         <p:spPr>
           <a:xfrm>
-            <a:off x="685800" y="2958465"/>
+            <a:off x="685800" y="2959396"/>
             <a:ext cx="411480" cy="182880"/>
           </a:xfrm>
           <a:prstGeom prst="rect">
@@ -6947,7 +6947,7 @@
         </p:nvSpPr>
         <p:spPr>
           <a:xfrm>
-            <a:off x="685800" y="2945130"/>
+            <a:off x="685800" y="2946991"/>
             <a:ext cx="411480" cy="182880"/>
           </a:xfrm>
           <a:prstGeom prst="rect">
@@ -6982,7 +6982,7 @@
         </p:nvSpPr>
         <p:spPr>
           <a:xfrm>
-            <a:off x="685800" y="2931795"/>
+            <a:off x="685800" y="2934587"/>
             <a:ext cx="411480" cy="182880"/>
           </a:xfrm>
           <a:prstGeom prst="rect">
@@ -7017,7 +7017,7 @@
         </p:nvSpPr>
         <p:spPr>
           <a:xfrm>
-            <a:off x="685800" y="2918460"/>
+            <a:off x="685800" y="2922182"/>
             <a:ext cx="411480" cy="182880"/>
           </a:xfrm>
           <a:prstGeom prst="rect">
@@ -7052,7 +7052,7 @@
         </p:nvSpPr>
         <p:spPr>
           <a:xfrm>
-            <a:off x="685800" y="2905125"/>
+            <a:off x="685800" y="2909777"/>
             <a:ext cx="411480" cy="182880"/>
           </a:xfrm>
           <a:prstGeom prst="rect">
@@ -7087,7 +7087,7 @@
         </p:nvSpPr>
         <p:spPr>
           <a:xfrm>
-            <a:off x="685800" y="2891790"/>
+            <a:off x="685800" y="2897373"/>
             <a:ext cx="411480" cy="182880"/>
           </a:xfrm>
           <a:prstGeom prst="rect">
@@ -7122,7 +7122,7 @@
         </p:nvSpPr>
         <p:spPr>
           <a:xfrm>
-            <a:off x="685800" y="2878455"/>
+            <a:off x="685800" y="2884968"/>
             <a:ext cx="411480" cy="182880"/>
           </a:xfrm>
           <a:prstGeom prst="rect">
@@ -7157,7 +7157,7 @@
         </p:nvSpPr>
         <p:spPr>
           <a:xfrm>
-            <a:off x="685800" y="2865120"/>
+            <a:off x="685800" y="2872563"/>
             <a:ext cx="411480" cy="182880"/>
           </a:xfrm>
           <a:prstGeom prst="rect">
@@ -7192,7 +7192,7 @@
         </p:nvSpPr>
         <p:spPr>
           <a:xfrm>
-            <a:off x="685800" y="2851785"/>
+            <a:off x="685800" y="2860159"/>
             <a:ext cx="411480" cy="182880"/>
           </a:xfrm>
           <a:prstGeom prst="rect">
@@ -7227,7 +7227,7 @@
         </p:nvSpPr>
         <p:spPr>
           <a:xfrm>
-            <a:off x="685800" y="2838450"/>
+            <a:off x="685800" y="2847754"/>
             <a:ext cx="411480" cy="182880"/>
           </a:xfrm>
           <a:prstGeom prst="rect">
@@ -7262,7 +7262,7 @@
         </p:nvSpPr>
         <p:spPr>
           <a:xfrm>
-            <a:off x="685800" y="2825115"/>
+            <a:off x="685800" y="2835349"/>
             <a:ext cx="411480" cy="182880"/>
           </a:xfrm>
           <a:prstGeom prst="rect">
@@ -7297,7 +7297,7 @@
         </p:nvSpPr>
         <p:spPr>
           <a:xfrm>
-            <a:off x="685800" y="2811780"/>
+            <a:off x="685800" y="2822945"/>
             <a:ext cx="411480" cy="182880"/>
           </a:xfrm>
           <a:prstGeom prst="rect">
@@ -7332,7 +7332,7 @@
         </p:nvSpPr>
         <p:spPr>
           <a:xfrm>
-            <a:off x="685800" y="2798445"/>
+            <a:off x="685800" y="2810540"/>
             <a:ext cx="411480" cy="182880"/>
           </a:xfrm>
           <a:prstGeom prst="rect">
@@ -7367,7 +7367,7 @@
         </p:nvSpPr>
         <p:spPr>
           <a:xfrm>
-            <a:off x="685800" y="2785110"/>
+            <a:off x="685800" y="2798135"/>
             <a:ext cx="411480" cy="182880"/>
           </a:xfrm>
           <a:prstGeom prst="rect">
@@ -7402,7 +7402,7 @@
         </p:nvSpPr>
         <p:spPr>
           <a:xfrm>
-            <a:off x="685800" y="2771775"/>
+            <a:off x="685800" y="2785731"/>
             <a:ext cx="411480" cy="182880"/>
           </a:xfrm>
           <a:prstGeom prst="rect">
@@ -7437,7 +7437,7 @@
         </p:nvSpPr>
         <p:spPr>
           <a:xfrm>
-            <a:off x="685800" y="2758440"/>
+            <a:off x="685800" y="2773326"/>
             <a:ext cx="411480" cy="182880"/>
           </a:xfrm>
           <a:prstGeom prst="rect">
@@ -7472,7 +7472,7 @@
         </p:nvSpPr>
         <p:spPr>
           <a:xfrm>
-            <a:off x="685800" y="2745105"/>
+            <a:off x="685800" y="2760921"/>
             <a:ext cx="411480" cy="182880"/>
           </a:xfrm>
           <a:prstGeom prst="rect">
@@ -7507,7 +7507,7 @@
         </p:nvSpPr>
         <p:spPr>
           <a:xfrm>
-            <a:off x="685800" y="2731770"/>
+            <a:off x="685800" y="2748517"/>
             <a:ext cx="411480" cy="182880"/>
           </a:xfrm>
           <a:prstGeom prst="rect">
@@ -7542,7 +7542,7 @@
         </p:nvSpPr>
         <p:spPr>
           <a:xfrm>
-            <a:off x="685800" y="2718435"/>
+            <a:off x="685800" y="2736112"/>
             <a:ext cx="411480" cy="182880"/>
           </a:xfrm>
           <a:prstGeom prst="rect">
@@ -7577,7 +7577,7 @@
         </p:nvSpPr>
         <p:spPr>
           <a:xfrm>
-            <a:off x="685800" y="2705100"/>
+            <a:off x="685800" y="2723707"/>
             <a:ext cx="411480" cy="182880"/>
           </a:xfrm>
           <a:prstGeom prst="rect">
@@ -7612,7 +7612,7 @@
         </p:nvSpPr>
         <p:spPr>
           <a:xfrm>
-            <a:off x="685800" y="2691765"/>
+            <a:off x="685800" y="2711303"/>
             <a:ext cx="411480" cy="182880"/>
           </a:xfrm>
           <a:prstGeom prst="rect">
@@ -7647,7 +7647,7 @@
         </p:nvSpPr>
         <p:spPr>
           <a:xfrm>
-            <a:off x="685800" y="2678430"/>
+            <a:off x="685800" y="2698898"/>
             <a:ext cx="411480" cy="182880"/>
           </a:xfrm>
           <a:prstGeom prst="rect">
@@ -7682,7 +7682,7 @@
         </p:nvSpPr>
         <p:spPr>
           <a:xfrm>
-            <a:off x="685800" y="2665095"/>
+            <a:off x="685800" y="2686494"/>
             <a:ext cx="411480" cy="182880"/>
           </a:xfrm>
           <a:prstGeom prst="rect">
@@ -7717,7 +7717,7 @@
         </p:nvSpPr>
         <p:spPr>
           <a:xfrm>
-            <a:off x="685800" y="2651760"/>
+            <a:off x="685800" y="2674089"/>
             <a:ext cx="411480" cy="182880"/>
           </a:xfrm>
           <a:prstGeom prst="rect">
@@ -7752,7 +7752,7 @@
         </p:nvSpPr>
         <p:spPr>
           <a:xfrm>
-            <a:off x="685800" y="2638425"/>
+            <a:off x="685800" y="2661684"/>
             <a:ext cx="411480" cy="182880"/>
           </a:xfrm>
           <a:prstGeom prst="rect">
@@ -7787,7 +7787,7 @@
         </p:nvSpPr>
         <p:spPr>
           <a:xfrm>
-            <a:off x="685800" y="2625090"/>
+            <a:off x="685800" y="2649280"/>
             <a:ext cx="411480" cy="182880"/>
           </a:xfrm>
           <a:prstGeom prst="rect">
@@ -7822,7 +7822,7 @@
         </p:nvSpPr>
         <p:spPr>
           <a:xfrm>
-            <a:off x="685800" y="2611755"/>
+            <a:off x="685800" y="2636875"/>
             <a:ext cx="411480" cy="182880"/>
           </a:xfrm>
           <a:prstGeom prst="rect">
@@ -7857,7 +7857,7 @@
         </p:nvSpPr>
         <p:spPr>
           <a:xfrm>
-            <a:off x="685800" y="2598420"/>
+            <a:off x="685800" y="2624470"/>
             <a:ext cx="411480" cy="182880"/>
           </a:xfrm>
           <a:prstGeom prst="rect">
@@ -7892,7 +7892,7 @@
         </p:nvSpPr>
         <p:spPr>
           <a:xfrm>
-            <a:off x="685800" y="2585085"/>
+            <a:off x="685800" y="2612066"/>
             <a:ext cx="411480" cy="182880"/>
           </a:xfrm>
           <a:prstGeom prst="rect">
@@ -7927,7 +7927,7 @@
         </p:nvSpPr>
         <p:spPr>
           <a:xfrm>
-            <a:off x="685800" y="2571750"/>
+            <a:off x="685800" y="2599661"/>
             <a:ext cx="411480" cy="182880"/>
           </a:xfrm>
           <a:prstGeom prst="rect">
@@ -7962,7 +7962,7 @@
         </p:nvSpPr>
         <p:spPr>
           <a:xfrm>
-            <a:off x="685800" y="2558415"/>
+            <a:off x="685800" y="2587256"/>
             <a:ext cx="411480" cy="182880"/>
           </a:xfrm>
           <a:prstGeom prst="rect">
@@ -7997,7 +7997,7 @@
         </p:nvSpPr>
         <p:spPr>
           <a:xfrm>
-            <a:off x="685800" y="2545080"/>
+            <a:off x="685800" y="2574852"/>
             <a:ext cx="411480" cy="182880"/>
           </a:xfrm>
           <a:prstGeom prst="rect">
@@ -8032,7 +8032,7 @@
         </p:nvSpPr>
         <p:spPr>
           <a:xfrm>
-            <a:off x="685800" y="2531745"/>
+            <a:off x="685800" y="2562447"/>
             <a:ext cx="411480" cy="182880"/>
           </a:xfrm>
           <a:prstGeom prst="rect">
@@ -8067,7 +8067,7 @@
         </p:nvSpPr>
         <p:spPr>
           <a:xfrm>
-            <a:off x="685800" y="2518410"/>
+            <a:off x="685800" y="2550042"/>
             <a:ext cx="411480" cy="182880"/>
           </a:xfrm>
           <a:prstGeom prst="rect">
@@ -8102,7 +8102,7 @@
         </p:nvSpPr>
         <p:spPr>
           <a:xfrm>
-            <a:off x="685800" y="2505075"/>
+            <a:off x="685800" y="2537638"/>
             <a:ext cx="411480" cy="182880"/>
           </a:xfrm>
           <a:prstGeom prst="rect">
@@ -8137,7 +8137,7 @@
         </p:nvSpPr>
         <p:spPr>
           <a:xfrm>
-            <a:off x="685800" y="2491740"/>
+            <a:off x="685800" y="2525233"/>
             <a:ext cx="411480" cy="182880"/>
           </a:xfrm>
           <a:prstGeom prst="rect">
@@ -8172,7 +8172,7 @@
         </p:nvSpPr>
         <p:spPr>
           <a:xfrm>
-            <a:off x="685800" y="2478405"/>
+            <a:off x="685800" y="2512828"/>
             <a:ext cx="411480" cy="182880"/>
           </a:xfrm>
           <a:prstGeom prst="rect">
@@ -8207,7 +8207,7 @@
         </p:nvSpPr>
         <p:spPr>
           <a:xfrm>
-            <a:off x="685800" y="2465070"/>
+            <a:off x="685800" y="2500424"/>
             <a:ext cx="411480" cy="182880"/>
           </a:xfrm>
           <a:prstGeom prst="rect">
@@ -8242,7 +8242,7 @@
         </p:nvSpPr>
         <p:spPr>
           <a:xfrm>
-            <a:off x="685800" y="2451735"/>
+            <a:off x="685800" y="2488019"/>
             <a:ext cx="411480" cy="182880"/>
           </a:xfrm>
           <a:prstGeom prst="rect">
@@ -8272,6 +8272,111 @@
       <p:sp>
         <p:nvSpPr>
           <p:cNvPr id="48" name="TextBox 47"/>
+          <p:cNvSpPr txBox="1"/>
+          <p:nvPr/>
+        </p:nvSpPr>
+        <p:spPr>
+          <a:xfrm>
+            <a:off x="685800" y="2475614"/>
+            <a:ext cx="411480" cy="182880"/>
+          </a:xfrm>
+          <a:prstGeom prst="rect">
+            <a:avLst/>
+          </a:prstGeom>
+          <a:noFill/>
+        </p:spPr>
+        <p:txBody>
+          <a:bodyPr wrap="square" lIns="0" rIns="0" tIns="0" bIns="0">
+            <a:spAutoFit/>
+          </a:bodyPr>
+          <a:lstStyle/>
+          <a:p>
+            <a:pPr algn="r"/>
+            <a:r>
+              <a:rPr sz="900" b="0">
+                <a:solidFill>
+                  <a:srgbClr val="718096"/>
+                </a:solidFill>
+                <a:latin typeface="Calibri"/>
+              </a:rPr>
+              <a:t>40</a:t>
+            </a:r>
+          </a:p>
+        </p:txBody>
+      </p:sp>
+      <p:sp>
+        <p:nvSpPr>
+          <p:cNvPr id="49" name="TextBox 48"/>
+          <p:cNvSpPr txBox="1"/>
+          <p:nvPr/>
+        </p:nvSpPr>
+        <p:spPr>
+          <a:xfrm>
+            <a:off x="685800" y="2463210"/>
+            <a:ext cx="411480" cy="182880"/>
+          </a:xfrm>
+          <a:prstGeom prst="rect">
+            <a:avLst/>
+          </a:prstGeom>
+          <a:noFill/>
+        </p:spPr>
+        <p:txBody>
+          <a:bodyPr wrap="square" lIns="0" rIns="0" tIns="0" bIns="0">
+            <a:spAutoFit/>
+          </a:bodyPr>
+          <a:lstStyle/>
+          <a:p>
+            <a:pPr algn="r"/>
+            <a:r>
+              <a:rPr sz="900" b="0">
+                <a:solidFill>
+                  <a:srgbClr val="718096"/>
+                </a:solidFill>
+                <a:latin typeface="Calibri"/>
+              </a:rPr>
+              <a:t>41</a:t>
+            </a:r>
+          </a:p>
+        </p:txBody>
+      </p:sp>
+      <p:sp>
+        <p:nvSpPr>
+          <p:cNvPr id="50" name="TextBox 49"/>
+          <p:cNvSpPr txBox="1"/>
+          <p:nvPr/>
+        </p:nvSpPr>
+        <p:spPr>
+          <a:xfrm>
+            <a:off x="685800" y="2450805"/>
+            <a:ext cx="411480" cy="182880"/>
+          </a:xfrm>
+          <a:prstGeom prst="rect">
+            <a:avLst/>
+          </a:prstGeom>
+          <a:noFill/>
+        </p:spPr>
+        <p:txBody>
+          <a:bodyPr wrap="square" lIns="0" rIns="0" tIns="0" bIns="0">
+            <a:spAutoFit/>
+          </a:bodyPr>
+          <a:lstStyle/>
+          <a:p>
+            <a:pPr algn="r"/>
+            <a:r>
+              <a:rPr sz="900" b="0">
+                <a:solidFill>
+                  <a:srgbClr val="718096"/>
+                </a:solidFill>
+                <a:latin typeface="Calibri"/>
+              </a:rPr>
+              <a:t>42</a:t>
+            </a:r>
+          </a:p>
+        </p:txBody>
+      </p:sp>
+      <p:sp>
+        <p:nvSpPr>
+          <p:cNvPr id="51" name="TextBox 50"/>
           <p:cNvSpPr txBox="1"/>
           <p:nvPr/>
         </p:nvSpPr>
@@ -8299,20 +8404,20 @@
                 </a:solidFill>
                 <a:latin typeface="Calibri"/>
               </a:rPr>
-              <a:t>40</a:t>
-            </a:r>
-          </a:p>
-        </p:txBody>
-      </p:sp>
-      <p:sp>
-        <p:nvSpPr>
-          <p:cNvPr id="49" name="TextBox 48"/>
-          <p:cNvSpPr txBox="1"/>
-          <p:nvPr/>
-        </p:nvSpPr>
-        <p:spPr>
-          <a:xfrm>
-            <a:off x="685800" y="2425065"/>
+              <a:t>43</a:t>
+            </a:r>
+          </a:p>
+        </p:txBody>
+      </p:sp>
+      <p:sp>
+        <p:nvSpPr>
+          <p:cNvPr id="52" name="TextBox 51"/>
+          <p:cNvSpPr txBox="1"/>
+          <p:nvPr/>
+        </p:nvSpPr>
+        <p:spPr>
+          <a:xfrm>
+            <a:off x="685800" y="2425996"/>
             <a:ext cx="411480" cy="182880"/>
           </a:xfrm>
           <a:prstGeom prst="rect">
@@ -8334,20 +8439,20 @@
                 </a:solidFill>
                 <a:latin typeface="Calibri"/>
               </a:rPr>
-              <a:t>41</a:t>
-            </a:r>
-          </a:p>
-        </p:txBody>
-      </p:sp>
-      <p:sp>
-        <p:nvSpPr>
-          <p:cNvPr id="50" name="TextBox 49"/>
-          <p:cNvSpPr txBox="1"/>
-          <p:nvPr/>
-        </p:nvSpPr>
-        <p:spPr>
-          <a:xfrm>
-            <a:off x="685800" y="2411730"/>
+              <a:t>44</a:t>
+            </a:r>
+          </a:p>
+        </p:txBody>
+      </p:sp>
+      <p:sp>
+        <p:nvSpPr>
+          <p:cNvPr id="53" name="TextBox 52"/>
+          <p:cNvSpPr txBox="1"/>
+          <p:nvPr/>
+        </p:nvSpPr>
+        <p:spPr>
+          <a:xfrm>
+            <a:off x="685800" y="2413591"/>
             <a:ext cx="411480" cy="182880"/>
           </a:xfrm>
           <a:prstGeom prst="rect">
@@ -8369,20 +8474,20 @@
                 </a:solidFill>
                 <a:latin typeface="Calibri"/>
               </a:rPr>
-              <a:t>42</a:t>
-            </a:r>
-          </a:p>
-        </p:txBody>
-      </p:sp>
-      <p:sp>
-        <p:nvSpPr>
-          <p:cNvPr id="51" name="TextBox 50"/>
-          <p:cNvSpPr txBox="1"/>
-          <p:nvPr/>
-        </p:nvSpPr>
-        <p:spPr>
-          <a:xfrm>
-            <a:off x="685800" y="2398395"/>
+              <a:t>45</a:t>
+            </a:r>
+          </a:p>
+        </p:txBody>
+      </p:sp>
+      <p:sp>
+        <p:nvSpPr>
+          <p:cNvPr id="54" name="TextBox 53"/>
+          <p:cNvSpPr txBox="1"/>
+          <p:nvPr/>
+        </p:nvSpPr>
+        <p:spPr>
+          <a:xfrm>
+            <a:off x="685800" y="2401187"/>
             <a:ext cx="411480" cy="182880"/>
           </a:xfrm>
           <a:prstGeom prst="rect">
@@ -8404,20 +8509,20 @@
                 </a:solidFill>
                 <a:latin typeface="Calibri"/>
               </a:rPr>
-              <a:t>43</a:t>
-            </a:r>
-          </a:p>
-        </p:txBody>
-      </p:sp>
-      <p:sp>
-        <p:nvSpPr>
-          <p:cNvPr id="52" name="TextBox 51"/>
-          <p:cNvSpPr txBox="1"/>
-          <p:nvPr/>
-        </p:nvSpPr>
-        <p:spPr>
-          <a:xfrm>
-            <a:off x="685800" y="2385060"/>
+              <a:t>46</a:t>
+            </a:r>
+          </a:p>
+        </p:txBody>
+      </p:sp>
+      <p:sp>
+        <p:nvSpPr>
+          <p:cNvPr id="55" name="TextBox 54"/>
+          <p:cNvSpPr txBox="1"/>
+          <p:nvPr/>
+        </p:nvSpPr>
+        <p:spPr>
+          <a:xfrm>
+            <a:off x="685800" y="2388782"/>
             <a:ext cx="411480" cy="182880"/>
           </a:xfrm>
           <a:prstGeom prst="rect">
@@ -8439,20 +8544,20 @@
                 </a:solidFill>
                 <a:latin typeface="Calibri"/>
               </a:rPr>
-              <a:t>44</a:t>
-            </a:r>
-          </a:p>
-        </p:txBody>
-      </p:sp>
-      <p:sp>
-        <p:nvSpPr>
-          <p:cNvPr id="53" name="TextBox 52"/>
-          <p:cNvSpPr txBox="1"/>
-          <p:nvPr/>
-        </p:nvSpPr>
-        <p:spPr>
-          <a:xfrm>
-            <a:off x="685800" y="2371725"/>
+              <a:t>47</a:t>
+            </a:r>
+          </a:p>
+        </p:txBody>
+      </p:sp>
+      <p:sp>
+        <p:nvSpPr>
+          <p:cNvPr id="56" name="TextBox 55"/>
+          <p:cNvSpPr txBox="1"/>
+          <p:nvPr/>
+        </p:nvSpPr>
+        <p:spPr>
+          <a:xfrm>
+            <a:off x="685800" y="2376377"/>
             <a:ext cx="411480" cy="182880"/>
           </a:xfrm>
           <a:prstGeom prst="rect">
@@ -8474,20 +8579,20 @@
                 </a:solidFill>
                 <a:latin typeface="Calibri"/>
               </a:rPr>
-              <a:t>45</a:t>
-            </a:r>
-          </a:p>
-        </p:txBody>
-      </p:sp>
-      <p:sp>
-        <p:nvSpPr>
-          <p:cNvPr id="54" name="TextBox 53"/>
-          <p:cNvSpPr txBox="1"/>
-          <p:nvPr/>
-        </p:nvSpPr>
-        <p:spPr>
-          <a:xfrm>
-            <a:off x="685800" y="2358390"/>
+              <a:t>48</a:t>
+            </a:r>
+          </a:p>
+        </p:txBody>
+      </p:sp>
+      <p:sp>
+        <p:nvSpPr>
+          <p:cNvPr id="57" name="TextBox 56"/>
+          <p:cNvSpPr txBox="1"/>
+          <p:nvPr/>
+        </p:nvSpPr>
+        <p:spPr>
+          <a:xfrm>
+            <a:off x="685800" y="2363973"/>
             <a:ext cx="411480" cy="182880"/>
           </a:xfrm>
           <a:prstGeom prst="rect">
@@ -8509,20 +8614,20 @@
                 </a:solidFill>
                 <a:latin typeface="Calibri"/>
               </a:rPr>
-              <a:t>46</a:t>
-            </a:r>
-          </a:p>
-        </p:txBody>
-      </p:sp>
-      <p:sp>
-        <p:nvSpPr>
-          <p:cNvPr id="55" name="TextBox 54"/>
-          <p:cNvSpPr txBox="1"/>
-          <p:nvPr/>
-        </p:nvSpPr>
-        <p:spPr>
-          <a:xfrm>
-            <a:off x="685800" y="2345055"/>
+              <a:t>49</a:t>
+            </a:r>
+          </a:p>
+        </p:txBody>
+      </p:sp>
+      <p:sp>
+        <p:nvSpPr>
+          <p:cNvPr id="58" name="TextBox 57"/>
+          <p:cNvSpPr txBox="1"/>
+          <p:nvPr/>
+        </p:nvSpPr>
+        <p:spPr>
+          <a:xfrm>
+            <a:off x="685800" y="2351568"/>
             <a:ext cx="411480" cy="182880"/>
           </a:xfrm>
           <a:prstGeom prst="rect">
@@ -8544,20 +8649,20 @@
                 </a:solidFill>
                 <a:latin typeface="Calibri"/>
               </a:rPr>
-              <a:t>47</a:t>
-            </a:r>
-          </a:p>
-        </p:txBody>
-      </p:sp>
-      <p:sp>
-        <p:nvSpPr>
-          <p:cNvPr id="56" name="TextBox 55"/>
-          <p:cNvSpPr txBox="1"/>
-          <p:nvPr/>
-        </p:nvSpPr>
-        <p:spPr>
-          <a:xfrm>
-            <a:off x="685800" y="2331720"/>
+              <a:t>50</a:t>
+            </a:r>
+          </a:p>
+        </p:txBody>
+      </p:sp>
+      <p:sp>
+        <p:nvSpPr>
+          <p:cNvPr id="59" name="TextBox 58"/>
+          <p:cNvSpPr txBox="1"/>
+          <p:nvPr/>
+        </p:nvSpPr>
+        <p:spPr>
+          <a:xfrm>
+            <a:off x="685800" y="2339163"/>
             <a:ext cx="411480" cy="182880"/>
           </a:xfrm>
           <a:prstGeom prst="rect">
@@ -8579,20 +8684,20 @@
                 </a:solidFill>
                 <a:latin typeface="Calibri"/>
               </a:rPr>
-              <a:t>48</a:t>
-            </a:r>
-          </a:p>
-        </p:txBody>
-      </p:sp>
-      <p:sp>
-        <p:nvSpPr>
-          <p:cNvPr id="57" name="TextBox 56"/>
-          <p:cNvSpPr txBox="1"/>
-          <p:nvPr/>
-        </p:nvSpPr>
-        <p:spPr>
-          <a:xfrm>
-            <a:off x="685800" y="2318385"/>
+              <a:t>51</a:t>
+            </a:r>
+          </a:p>
+        </p:txBody>
+      </p:sp>
+      <p:sp>
+        <p:nvSpPr>
+          <p:cNvPr id="60" name="TextBox 59"/>
+          <p:cNvSpPr txBox="1"/>
+          <p:nvPr/>
+        </p:nvSpPr>
+        <p:spPr>
+          <a:xfrm>
+            <a:off x="685800" y="2326759"/>
             <a:ext cx="411480" cy="182880"/>
           </a:xfrm>
           <a:prstGeom prst="rect">
@@ -8614,20 +8719,20 @@
                 </a:solidFill>
                 <a:latin typeface="Calibri"/>
               </a:rPr>
-              <a:t>49</a:t>
-            </a:r>
-          </a:p>
-        </p:txBody>
-      </p:sp>
-      <p:sp>
-        <p:nvSpPr>
-          <p:cNvPr id="58" name="TextBox 57"/>
-          <p:cNvSpPr txBox="1"/>
-          <p:nvPr/>
-        </p:nvSpPr>
-        <p:spPr>
-          <a:xfrm>
-            <a:off x="685800" y="2305050"/>
+              <a:t>52</a:t>
+            </a:r>
+          </a:p>
+        </p:txBody>
+      </p:sp>
+      <p:sp>
+        <p:nvSpPr>
+          <p:cNvPr id="61" name="TextBox 60"/>
+          <p:cNvSpPr txBox="1"/>
+          <p:nvPr/>
+        </p:nvSpPr>
+        <p:spPr>
+          <a:xfrm>
+            <a:off x="685800" y="2314354"/>
             <a:ext cx="411480" cy="182880"/>
           </a:xfrm>
           <a:prstGeom prst="rect">
@@ -8649,20 +8754,20 @@
                 </a:solidFill>
                 <a:latin typeface="Calibri"/>
               </a:rPr>
-              <a:t>50</a:t>
-            </a:r>
-          </a:p>
-        </p:txBody>
-      </p:sp>
-      <p:sp>
-        <p:nvSpPr>
-          <p:cNvPr id="59" name="TextBox 58"/>
-          <p:cNvSpPr txBox="1"/>
-          <p:nvPr/>
-        </p:nvSpPr>
-        <p:spPr>
-          <a:xfrm>
-            <a:off x="685800" y="2291715"/>
+              <a:t>53</a:t>
+            </a:r>
+          </a:p>
+        </p:txBody>
+      </p:sp>
+      <p:sp>
+        <p:nvSpPr>
+          <p:cNvPr id="62" name="TextBox 61"/>
+          <p:cNvSpPr txBox="1"/>
+          <p:nvPr/>
+        </p:nvSpPr>
+        <p:spPr>
+          <a:xfrm>
+            <a:off x="685800" y="2301949"/>
             <a:ext cx="411480" cy="182880"/>
           </a:xfrm>
           <a:prstGeom prst="rect">
@@ -8684,20 +8789,20 @@
                 </a:solidFill>
                 <a:latin typeface="Calibri"/>
               </a:rPr>
-              <a:t>51</a:t>
-            </a:r>
-          </a:p>
-        </p:txBody>
-      </p:sp>
-      <p:sp>
-        <p:nvSpPr>
-          <p:cNvPr id="60" name="TextBox 59"/>
-          <p:cNvSpPr txBox="1"/>
-          <p:nvPr/>
-        </p:nvSpPr>
-        <p:spPr>
-          <a:xfrm>
-            <a:off x="685800" y="2278380"/>
+              <a:t>54</a:t>
+            </a:r>
+          </a:p>
+        </p:txBody>
+      </p:sp>
+      <p:sp>
+        <p:nvSpPr>
+          <p:cNvPr id="63" name="TextBox 62"/>
+          <p:cNvSpPr txBox="1"/>
+          <p:nvPr/>
+        </p:nvSpPr>
+        <p:spPr>
+          <a:xfrm>
+            <a:off x="685800" y="2289545"/>
             <a:ext cx="411480" cy="182880"/>
           </a:xfrm>
           <a:prstGeom prst="rect">
@@ -8719,20 +8824,20 @@
                 </a:solidFill>
                 <a:latin typeface="Calibri"/>
               </a:rPr>
-              <a:t>52</a:t>
-            </a:r>
-          </a:p>
-        </p:txBody>
-      </p:sp>
-      <p:sp>
-        <p:nvSpPr>
-          <p:cNvPr id="61" name="TextBox 60"/>
-          <p:cNvSpPr txBox="1"/>
-          <p:nvPr/>
-        </p:nvSpPr>
-        <p:spPr>
-          <a:xfrm>
-            <a:off x="685800" y="2265045"/>
+              <a:t>55</a:t>
+            </a:r>
+          </a:p>
+        </p:txBody>
+      </p:sp>
+      <p:sp>
+        <p:nvSpPr>
+          <p:cNvPr id="64" name="TextBox 63"/>
+          <p:cNvSpPr txBox="1"/>
+          <p:nvPr/>
+        </p:nvSpPr>
+        <p:spPr>
+          <a:xfrm>
+            <a:off x="685800" y="2277140"/>
             <a:ext cx="411480" cy="182880"/>
           </a:xfrm>
           <a:prstGeom prst="rect">
@@ -8754,20 +8859,20 @@
                 </a:solidFill>
                 <a:latin typeface="Calibri"/>
               </a:rPr>
-              <a:t>53</a:t>
-            </a:r>
-          </a:p>
-        </p:txBody>
-      </p:sp>
-      <p:sp>
-        <p:nvSpPr>
-          <p:cNvPr id="62" name="TextBox 61"/>
-          <p:cNvSpPr txBox="1"/>
-          <p:nvPr/>
-        </p:nvSpPr>
-        <p:spPr>
-          <a:xfrm>
-            <a:off x="685800" y="2251710"/>
+              <a:t>56</a:t>
+            </a:r>
+          </a:p>
+        </p:txBody>
+      </p:sp>
+      <p:sp>
+        <p:nvSpPr>
+          <p:cNvPr id="65" name="TextBox 64"/>
+          <p:cNvSpPr txBox="1"/>
+          <p:nvPr/>
+        </p:nvSpPr>
+        <p:spPr>
+          <a:xfrm>
+            <a:off x="685800" y="2264735"/>
             <a:ext cx="411480" cy="182880"/>
           </a:xfrm>
           <a:prstGeom prst="rect">
@@ -8789,20 +8894,20 @@
                 </a:solidFill>
                 <a:latin typeface="Calibri"/>
               </a:rPr>
-              <a:t>54</a:t>
-            </a:r>
-          </a:p>
-        </p:txBody>
-      </p:sp>
-      <p:sp>
-        <p:nvSpPr>
-          <p:cNvPr id="63" name="TextBox 62"/>
-          <p:cNvSpPr txBox="1"/>
-          <p:nvPr/>
-        </p:nvSpPr>
-        <p:spPr>
-          <a:xfrm>
-            <a:off x="685800" y="2238375"/>
+              <a:t>57</a:t>
+            </a:r>
+          </a:p>
+        </p:txBody>
+      </p:sp>
+      <p:sp>
+        <p:nvSpPr>
+          <p:cNvPr id="66" name="TextBox 65"/>
+          <p:cNvSpPr txBox="1"/>
+          <p:nvPr/>
+        </p:nvSpPr>
+        <p:spPr>
+          <a:xfrm>
+            <a:off x="685800" y="2252331"/>
             <a:ext cx="411480" cy="182880"/>
           </a:xfrm>
           <a:prstGeom prst="rect">
@@ -8824,20 +8929,20 @@
                 </a:solidFill>
                 <a:latin typeface="Calibri"/>
               </a:rPr>
-              <a:t>55</a:t>
-            </a:r>
-          </a:p>
-        </p:txBody>
-      </p:sp>
-      <p:sp>
-        <p:nvSpPr>
-          <p:cNvPr id="64" name="TextBox 63"/>
-          <p:cNvSpPr txBox="1"/>
-          <p:nvPr/>
-        </p:nvSpPr>
-        <p:spPr>
-          <a:xfrm>
-            <a:off x="685800" y="2225040"/>
+              <a:t>58</a:t>
+            </a:r>
+          </a:p>
+        </p:txBody>
+      </p:sp>
+      <p:sp>
+        <p:nvSpPr>
+          <p:cNvPr id="67" name="TextBox 66"/>
+          <p:cNvSpPr txBox="1"/>
+          <p:nvPr/>
+        </p:nvSpPr>
+        <p:spPr>
+          <a:xfrm>
+            <a:off x="685800" y="2239926"/>
             <a:ext cx="411480" cy="182880"/>
           </a:xfrm>
           <a:prstGeom prst="rect">
@@ -8859,20 +8964,20 @@
                 </a:solidFill>
                 <a:latin typeface="Calibri"/>
               </a:rPr>
-              <a:t>56</a:t>
-            </a:r>
-          </a:p>
-        </p:txBody>
-      </p:sp>
-      <p:sp>
-        <p:nvSpPr>
-          <p:cNvPr id="65" name="TextBox 64"/>
-          <p:cNvSpPr txBox="1"/>
-          <p:nvPr/>
-        </p:nvSpPr>
-        <p:spPr>
-          <a:xfrm>
-            <a:off x="685800" y="2211705"/>
+              <a:t>59</a:t>
+            </a:r>
+          </a:p>
+        </p:txBody>
+      </p:sp>
+      <p:sp>
+        <p:nvSpPr>
+          <p:cNvPr id="68" name="TextBox 67"/>
+          <p:cNvSpPr txBox="1"/>
+          <p:nvPr/>
+        </p:nvSpPr>
+        <p:spPr>
+          <a:xfrm>
+            <a:off x="685800" y="2227521"/>
             <a:ext cx="411480" cy="182880"/>
           </a:xfrm>
           <a:prstGeom prst="rect">
@@ -8894,20 +8999,20 @@
                 </a:solidFill>
                 <a:latin typeface="Calibri"/>
               </a:rPr>
-              <a:t>57</a:t>
-            </a:r>
-          </a:p>
-        </p:txBody>
-      </p:sp>
-      <p:sp>
-        <p:nvSpPr>
-          <p:cNvPr id="66" name="TextBox 65"/>
-          <p:cNvSpPr txBox="1"/>
-          <p:nvPr/>
-        </p:nvSpPr>
-        <p:spPr>
-          <a:xfrm>
-            <a:off x="685800" y="2198370"/>
+              <a:t>60</a:t>
+            </a:r>
+          </a:p>
+        </p:txBody>
+      </p:sp>
+      <p:sp>
+        <p:nvSpPr>
+          <p:cNvPr id="69" name="TextBox 68"/>
+          <p:cNvSpPr txBox="1"/>
+          <p:nvPr/>
+        </p:nvSpPr>
+        <p:spPr>
+          <a:xfrm>
+            <a:off x="685800" y="2215117"/>
             <a:ext cx="411480" cy="182880"/>
           </a:xfrm>
           <a:prstGeom prst="rect">
@@ -8929,20 +9034,20 @@
                 </a:solidFill>
                 <a:latin typeface="Calibri"/>
               </a:rPr>
-              <a:t>58</a:t>
-            </a:r>
-          </a:p>
-        </p:txBody>
-      </p:sp>
-      <p:sp>
-        <p:nvSpPr>
-          <p:cNvPr id="67" name="TextBox 66"/>
-          <p:cNvSpPr txBox="1"/>
-          <p:nvPr/>
-        </p:nvSpPr>
-        <p:spPr>
-          <a:xfrm>
-            <a:off x="685800" y="2185035"/>
+              <a:t>61</a:t>
+            </a:r>
+          </a:p>
+        </p:txBody>
+      </p:sp>
+      <p:sp>
+        <p:nvSpPr>
+          <p:cNvPr id="70" name="TextBox 69"/>
+          <p:cNvSpPr txBox="1"/>
+          <p:nvPr/>
+        </p:nvSpPr>
+        <p:spPr>
+          <a:xfrm>
+            <a:off x="685800" y="2202712"/>
             <a:ext cx="411480" cy="182880"/>
           </a:xfrm>
           <a:prstGeom prst="rect">
@@ -8964,20 +9069,20 @@
                 </a:solidFill>
                 <a:latin typeface="Calibri"/>
               </a:rPr>
-              <a:t>59</a:t>
-            </a:r>
-          </a:p>
-        </p:txBody>
-      </p:sp>
-      <p:sp>
-        <p:nvSpPr>
-          <p:cNvPr id="68" name="TextBox 67"/>
-          <p:cNvSpPr txBox="1"/>
-          <p:nvPr/>
-        </p:nvSpPr>
-        <p:spPr>
-          <a:xfrm>
-            <a:off x="685800" y="2171700"/>
+              <a:t>62</a:t>
+            </a:r>
+          </a:p>
+        </p:txBody>
+      </p:sp>
+      <p:sp>
+        <p:nvSpPr>
+          <p:cNvPr id="71" name="TextBox 70"/>
+          <p:cNvSpPr txBox="1"/>
+          <p:nvPr/>
+        </p:nvSpPr>
+        <p:spPr>
+          <a:xfrm>
+            <a:off x="685800" y="2190307"/>
             <a:ext cx="411480" cy="182880"/>
           </a:xfrm>
           <a:prstGeom prst="rect">
@@ -8999,20 +9104,20 @@
                 </a:solidFill>
                 <a:latin typeface="Calibri"/>
               </a:rPr>
-              <a:t>60</a:t>
-            </a:r>
-          </a:p>
-        </p:txBody>
-      </p:sp>
-      <p:sp>
-        <p:nvSpPr>
-          <p:cNvPr id="69" name="TextBox 68"/>
-          <p:cNvSpPr txBox="1"/>
-          <p:nvPr/>
-        </p:nvSpPr>
-        <p:spPr>
-          <a:xfrm>
-            <a:off x="685800" y="2158365"/>
+              <a:t>63</a:t>
+            </a:r>
+          </a:p>
+        </p:txBody>
+      </p:sp>
+      <p:sp>
+        <p:nvSpPr>
+          <p:cNvPr id="72" name="TextBox 71"/>
+          <p:cNvSpPr txBox="1"/>
+          <p:nvPr/>
+        </p:nvSpPr>
+        <p:spPr>
+          <a:xfrm>
+            <a:off x="685800" y="2177903"/>
             <a:ext cx="411480" cy="182880"/>
           </a:xfrm>
           <a:prstGeom prst="rect">
@@ -9034,20 +9139,20 @@
                 </a:solidFill>
                 <a:latin typeface="Calibri"/>
               </a:rPr>
-              <a:t>61</a:t>
-            </a:r>
-          </a:p>
-        </p:txBody>
-      </p:sp>
-      <p:sp>
-        <p:nvSpPr>
-          <p:cNvPr id="70" name="TextBox 69"/>
-          <p:cNvSpPr txBox="1"/>
-          <p:nvPr/>
-        </p:nvSpPr>
-        <p:spPr>
-          <a:xfrm>
-            <a:off x="685800" y="2145030"/>
+              <a:t>64</a:t>
+            </a:r>
+          </a:p>
+        </p:txBody>
+      </p:sp>
+      <p:sp>
+        <p:nvSpPr>
+          <p:cNvPr id="73" name="TextBox 72"/>
+          <p:cNvSpPr txBox="1"/>
+          <p:nvPr/>
+        </p:nvSpPr>
+        <p:spPr>
+          <a:xfrm>
+            <a:off x="685800" y="2165498"/>
             <a:ext cx="411480" cy="182880"/>
           </a:xfrm>
           <a:prstGeom prst="rect">
@@ -9069,20 +9174,20 @@
                 </a:solidFill>
                 <a:latin typeface="Calibri"/>
               </a:rPr>
-              <a:t>62</a:t>
-            </a:r>
-          </a:p>
-        </p:txBody>
-      </p:sp>
-      <p:sp>
-        <p:nvSpPr>
-          <p:cNvPr id="71" name="TextBox 70"/>
-          <p:cNvSpPr txBox="1"/>
-          <p:nvPr/>
-        </p:nvSpPr>
-        <p:spPr>
-          <a:xfrm>
-            <a:off x="685800" y="2131695"/>
+              <a:t>65</a:t>
+            </a:r>
+          </a:p>
+        </p:txBody>
+      </p:sp>
+      <p:sp>
+        <p:nvSpPr>
+          <p:cNvPr id="74" name="TextBox 73"/>
+          <p:cNvSpPr txBox="1"/>
+          <p:nvPr/>
+        </p:nvSpPr>
+        <p:spPr>
+          <a:xfrm>
+            <a:off x="685800" y="2153094"/>
             <a:ext cx="411480" cy="182880"/>
           </a:xfrm>
           <a:prstGeom prst="rect">
@@ -9104,20 +9209,20 @@
                 </a:solidFill>
                 <a:latin typeface="Calibri"/>
               </a:rPr>
-              <a:t>63</a:t>
-            </a:r>
-          </a:p>
-        </p:txBody>
-      </p:sp>
-      <p:sp>
-        <p:nvSpPr>
-          <p:cNvPr id="72" name="TextBox 71"/>
-          <p:cNvSpPr txBox="1"/>
-          <p:nvPr/>
-        </p:nvSpPr>
-        <p:spPr>
-          <a:xfrm>
-            <a:off x="685800" y="2118360"/>
+              <a:t>66</a:t>
+            </a:r>
+          </a:p>
+        </p:txBody>
+      </p:sp>
+      <p:sp>
+        <p:nvSpPr>
+          <p:cNvPr id="75" name="TextBox 74"/>
+          <p:cNvSpPr txBox="1"/>
+          <p:nvPr/>
+        </p:nvSpPr>
+        <p:spPr>
+          <a:xfrm>
+            <a:off x="685800" y="2140689"/>
             <a:ext cx="411480" cy="182880"/>
           </a:xfrm>
           <a:prstGeom prst="rect">
@@ -9139,20 +9244,20 @@
                 </a:solidFill>
                 <a:latin typeface="Calibri"/>
               </a:rPr>
-              <a:t>64</a:t>
-            </a:r>
-          </a:p>
-        </p:txBody>
-      </p:sp>
-      <p:sp>
-        <p:nvSpPr>
-          <p:cNvPr id="73" name="TextBox 72"/>
-          <p:cNvSpPr txBox="1"/>
-          <p:nvPr/>
-        </p:nvSpPr>
-        <p:spPr>
-          <a:xfrm>
-            <a:off x="685800" y="2105026"/>
+              <a:t>67</a:t>
+            </a:r>
+          </a:p>
+        </p:txBody>
+      </p:sp>
+      <p:sp>
+        <p:nvSpPr>
+          <p:cNvPr id="76" name="TextBox 75"/>
+          <p:cNvSpPr txBox="1"/>
+          <p:nvPr/>
+        </p:nvSpPr>
+        <p:spPr>
+          <a:xfrm>
+            <a:off x="685800" y="2128284"/>
             <a:ext cx="411480" cy="182880"/>
           </a:xfrm>
           <a:prstGeom prst="rect">
@@ -9174,20 +9279,20 @@
                 </a:solidFill>
                 <a:latin typeface="Calibri"/>
               </a:rPr>
-              <a:t>65</a:t>
-            </a:r>
-          </a:p>
-        </p:txBody>
-      </p:sp>
-      <p:sp>
-        <p:nvSpPr>
-          <p:cNvPr id="74" name="TextBox 73"/>
-          <p:cNvSpPr txBox="1"/>
-          <p:nvPr/>
-        </p:nvSpPr>
-        <p:spPr>
-          <a:xfrm>
-            <a:off x="685800" y="2091690"/>
+              <a:t>68</a:t>
+            </a:r>
+          </a:p>
+        </p:txBody>
+      </p:sp>
+      <p:sp>
+        <p:nvSpPr>
+          <p:cNvPr id="77" name="TextBox 76"/>
+          <p:cNvSpPr txBox="1"/>
+          <p:nvPr/>
+        </p:nvSpPr>
+        <p:spPr>
+          <a:xfrm>
+            <a:off x="685800" y="2115880"/>
             <a:ext cx="411480" cy="182880"/>
           </a:xfrm>
           <a:prstGeom prst="rect">
@@ -9209,20 +9314,20 @@
                 </a:solidFill>
                 <a:latin typeface="Calibri"/>
               </a:rPr>
-              <a:t>66</a:t>
-            </a:r>
-          </a:p>
-        </p:txBody>
-      </p:sp>
-      <p:sp>
-        <p:nvSpPr>
-          <p:cNvPr id="75" name="TextBox 74"/>
-          <p:cNvSpPr txBox="1"/>
-          <p:nvPr/>
-        </p:nvSpPr>
-        <p:spPr>
-          <a:xfrm>
-            <a:off x="685800" y="2078355"/>
+              <a:t>69</a:t>
+            </a:r>
+          </a:p>
+        </p:txBody>
+      </p:sp>
+      <p:sp>
+        <p:nvSpPr>
+          <p:cNvPr id="78" name="TextBox 77"/>
+          <p:cNvSpPr txBox="1"/>
+          <p:nvPr/>
+        </p:nvSpPr>
+        <p:spPr>
+          <a:xfrm>
+            <a:off x="685800" y="2103475"/>
             <a:ext cx="411480" cy="182880"/>
           </a:xfrm>
           <a:prstGeom prst="rect">
@@ -9244,20 +9349,20 @@
                 </a:solidFill>
                 <a:latin typeface="Calibri"/>
               </a:rPr>
-              <a:t>67</a:t>
-            </a:r>
-          </a:p>
-        </p:txBody>
-      </p:sp>
-      <p:sp>
-        <p:nvSpPr>
-          <p:cNvPr id="76" name="TextBox 75"/>
-          <p:cNvSpPr txBox="1"/>
-          <p:nvPr/>
-        </p:nvSpPr>
-        <p:spPr>
-          <a:xfrm>
-            <a:off x="685800" y="2065020"/>
+              <a:t>70</a:t>
+            </a:r>
+          </a:p>
+        </p:txBody>
+      </p:sp>
+      <p:sp>
+        <p:nvSpPr>
+          <p:cNvPr id="79" name="TextBox 78"/>
+          <p:cNvSpPr txBox="1"/>
+          <p:nvPr/>
+        </p:nvSpPr>
+        <p:spPr>
+          <a:xfrm>
+            <a:off x="685800" y="2091070"/>
             <a:ext cx="411480" cy="182880"/>
           </a:xfrm>
           <a:prstGeom prst="rect">
@@ -9279,20 +9384,20 @@
                 </a:solidFill>
                 <a:latin typeface="Calibri"/>
               </a:rPr>
-              <a:t>68</a:t>
-            </a:r>
-          </a:p>
-        </p:txBody>
-      </p:sp>
-      <p:sp>
-        <p:nvSpPr>
-          <p:cNvPr id="77" name="TextBox 76"/>
-          <p:cNvSpPr txBox="1"/>
-          <p:nvPr/>
-        </p:nvSpPr>
-        <p:spPr>
-          <a:xfrm>
-            <a:off x="685800" y="2051686"/>
+              <a:t>71</a:t>
+            </a:r>
+          </a:p>
+        </p:txBody>
+      </p:sp>
+      <p:sp>
+        <p:nvSpPr>
+          <p:cNvPr id="80" name="TextBox 79"/>
+          <p:cNvSpPr txBox="1"/>
+          <p:nvPr/>
+        </p:nvSpPr>
+        <p:spPr>
+          <a:xfrm>
+            <a:off x="685800" y="2078666"/>
             <a:ext cx="411480" cy="182880"/>
           </a:xfrm>
           <a:prstGeom prst="rect">
@@ -9314,20 +9419,20 @@
                 </a:solidFill>
                 <a:latin typeface="Calibri"/>
               </a:rPr>
-              <a:t>69</a:t>
-            </a:r>
-          </a:p>
-        </p:txBody>
-      </p:sp>
-      <p:sp>
-        <p:nvSpPr>
-          <p:cNvPr id="78" name="TextBox 77"/>
-          <p:cNvSpPr txBox="1"/>
-          <p:nvPr/>
-        </p:nvSpPr>
-        <p:spPr>
-          <a:xfrm>
-            <a:off x="685800" y="2038350"/>
+              <a:t>72</a:t>
+            </a:r>
+          </a:p>
+        </p:txBody>
+      </p:sp>
+      <p:sp>
+        <p:nvSpPr>
+          <p:cNvPr id="81" name="TextBox 80"/>
+          <p:cNvSpPr txBox="1"/>
+          <p:nvPr/>
+        </p:nvSpPr>
+        <p:spPr>
+          <a:xfrm>
+            <a:off x="685800" y="2066261"/>
             <a:ext cx="411480" cy="182880"/>
           </a:xfrm>
           <a:prstGeom prst="rect">
@@ -9349,20 +9454,20 @@
                 </a:solidFill>
                 <a:latin typeface="Calibri"/>
               </a:rPr>
-              <a:t>70</a:t>
-            </a:r>
-          </a:p>
-        </p:txBody>
-      </p:sp>
-      <p:sp>
-        <p:nvSpPr>
-          <p:cNvPr id="79" name="TextBox 78"/>
-          <p:cNvSpPr txBox="1"/>
-          <p:nvPr/>
-        </p:nvSpPr>
-        <p:spPr>
-          <a:xfrm>
-            <a:off x="685800" y="2025015"/>
+              <a:t>73</a:t>
+            </a:r>
+          </a:p>
+        </p:txBody>
+      </p:sp>
+      <p:sp>
+        <p:nvSpPr>
+          <p:cNvPr id="82" name="TextBox 81"/>
+          <p:cNvSpPr txBox="1"/>
+          <p:nvPr/>
+        </p:nvSpPr>
+        <p:spPr>
+          <a:xfrm>
+            <a:off x="685800" y="2053856"/>
             <a:ext cx="411480" cy="182880"/>
           </a:xfrm>
           <a:prstGeom prst="rect">
@@ -9384,20 +9489,20 @@
                 </a:solidFill>
                 <a:latin typeface="Calibri"/>
               </a:rPr>
-              <a:t>71</a:t>
-            </a:r>
-          </a:p>
-        </p:txBody>
-      </p:sp>
-      <p:sp>
-        <p:nvSpPr>
-          <p:cNvPr id="80" name="TextBox 79"/>
-          <p:cNvSpPr txBox="1"/>
-          <p:nvPr/>
-        </p:nvSpPr>
-        <p:spPr>
-          <a:xfrm>
-            <a:off x="685800" y="2011680"/>
+              <a:t>74</a:t>
+            </a:r>
+          </a:p>
+        </p:txBody>
+      </p:sp>
+      <p:sp>
+        <p:nvSpPr>
+          <p:cNvPr id="83" name="TextBox 82"/>
+          <p:cNvSpPr txBox="1"/>
+          <p:nvPr/>
+        </p:nvSpPr>
+        <p:spPr>
+          <a:xfrm>
+            <a:off x="685800" y="2041452"/>
             <a:ext cx="411480" cy="182880"/>
           </a:xfrm>
           <a:prstGeom prst="rect">
@@ -9419,20 +9524,20 @@
                 </a:solidFill>
                 <a:latin typeface="Calibri"/>
               </a:rPr>
-              <a:t>72</a:t>
-            </a:r>
-          </a:p>
-        </p:txBody>
-      </p:sp>
-      <p:sp>
-        <p:nvSpPr>
-          <p:cNvPr id="81" name="TextBox 80"/>
-          <p:cNvSpPr txBox="1"/>
-          <p:nvPr/>
-        </p:nvSpPr>
-        <p:spPr>
-          <a:xfrm>
-            <a:off x="685800" y="1998346"/>
+              <a:t>75</a:t>
+            </a:r>
+          </a:p>
+        </p:txBody>
+      </p:sp>
+      <p:sp>
+        <p:nvSpPr>
+          <p:cNvPr id="84" name="TextBox 83"/>
+          <p:cNvSpPr txBox="1"/>
+          <p:nvPr/>
+        </p:nvSpPr>
+        <p:spPr>
+          <a:xfrm>
+            <a:off x="685800" y="2029047"/>
             <a:ext cx="411480" cy="182880"/>
           </a:xfrm>
           <a:prstGeom prst="rect">
@@ -9454,20 +9559,20 @@
                 </a:solidFill>
                 <a:latin typeface="Calibri"/>
               </a:rPr>
-              <a:t>73</a:t>
-            </a:r>
-          </a:p>
-        </p:txBody>
-      </p:sp>
-      <p:sp>
-        <p:nvSpPr>
-          <p:cNvPr id="82" name="TextBox 81"/>
-          <p:cNvSpPr txBox="1"/>
-          <p:nvPr/>
-        </p:nvSpPr>
-        <p:spPr>
-          <a:xfrm>
-            <a:off x="685800" y="1985010"/>
+              <a:t>76</a:t>
+            </a:r>
+          </a:p>
+        </p:txBody>
+      </p:sp>
+      <p:sp>
+        <p:nvSpPr>
+          <p:cNvPr id="85" name="TextBox 84"/>
+          <p:cNvSpPr txBox="1"/>
+          <p:nvPr/>
+        </p:nvSpPr>
+        <p:spPr>
+          <a:xfrm>
+            <a:off x="685800" y="2016642"/>
             <a:ext cx="411480" cy="182880"/>
           </a:xfrm>
           <a:prstGeom prst="rect">
@@ -9489,20 +9594,20 @@
                 </a:solidFill>
                 <a:latin typeface="Calibri"/>
               </a:rPr>
-              <a:t>74</a:t>
-            </a:r>
-          </a:p>
-        </p:txBody>
-      </p:sp>
-      <p:sp>
-        <p:nvSpPr>
-          <p:cNvPr id="83" name="TextBox 82"/>
-          <p:cNvSpPr txBox="1"/>
-          <p:nvPr/>
-        </p:nvSpPr>
-        <p:spPr>
-          <a:xfrm>
-            <a:off x="685800" y="1971675"/>
+              <a:t>77</a:t>
+            </a:r>
+          </a:p>
+        </p:txBody>
+      </p:sp>
+      <p:sp>
+        <p:nvSpPr>
+          <p:cNvPr id="86" name="TextBox 85"/>
+          <p:cNvSpPr txBox="1"/>
+          <p:nvPr/>
+        </p:nvSpPr>
+        <p:spPr>
+          <a:xfrm>
+            <a:off x="685800" y="2004238"/>
             <a:ext cx="411480" cy="182880"/>
           </a:xfrm>
           <a:prstGeom prst="rect">
@@ -9524,20 +9629,20 @@
                 </a:solidFill>
                 <a:latin typeface="Calibri"/>
               </a:rPr>
-              <a:t>75</a:t>
-            </a:r>
-          </a:p>
-        </p:txBody>
-      </p:sp>
-      <p:sp>
-        <p:nvSpPr>
-          <p:cNvPr id="84" name="TextBox 83"/>
-          <p:cNvSpPr txBox="1"/>
-          <p:nvPr/>
-        </p:nvSpPr>
-        <p:spPr>
-          <a:xfrm>
-            <a:off x="685800" y="1958340"/>
+              <a:t>78</a:t>
+            </a:r>
+          </a:p>
+        </p:txBody>
+      </p:sp>
+      <p:sp>
+        <p:nvSpPr>
+          <p:cNvPr id="87" name="TextBox 86"/>
+          <p:cNvSpPr txBox="1"/>
+          <p:nvPr/>
+        </p:nvSpPr>
+        <p:spPr>
+          <a:xfrm>
+            <a:off x="685800" y="1991833"/>
             <a:ext cx="411480" cy="182880"/>
           </a:xfrm>
           <a:prstGeom prst="rect">
@@ -9559,20 +9664,20 @@
                 </a:solidFill>
                 <a:latin typeface="Calibri"/>
               </a:rPr>
-              <a:t>76</a:t>
-            </a:r>
-          </a:p>
-        </p:txBody>
-      </p:sp>
-      <p:sp>
-        <p:nvSpPr>
-          <p:cNvPr id="85" name="TextBox 84"/>
-          <p:cNvSpPr txBox="1"/>
-          <p:nvPr/>
-        </p:nvSpPr>
-        <p:spPr>
-          <a:xfrm>
-            <a:off x="685800" y="1945005"/>
+              <a:t>79</a:t>
+            </a:r>
+          </a:p>
+        </p:txBody>
+      </p:sp>
+      <p:sp>
+        <p:nvSpPr>
+          <p:cNvPr id="88" name="TextBox 87"/>
+          <p:cNvSpPr txBox="1"/>
+          <p:nvPr/>
+        </p:nvSpPr>
+        <p:spPr>
+          <a:xfrm>
+            <a:off x="685800" y="1979428"/>
             <a:ext cx="411480" cy="182880"/>
           </a:xfrm>
           <a:prstGeom prst="rect">
@@ -9594,20 +9699,20 @@
                 </a:solidFill>
                 <a:latin typeface="Calibri"/>
               </a:rPr>
-              <a:t>77</a:t>
-            </a:r>
-          </a:p>
-        </p:txBody>
-      </p:sp>
-      <p:sp>
-        <p:nvSpPr>
-          <p:cNvPr id="86" name="TextBox 85"/>
-          <p:cNvSpPr txBox="1"/>
-          <p:nvPr/>
-        </p:nvSpPr>
-        <p:spPr>
-          <a:xfrm>
-            <a:off x="685800" y="1931670"/>
+              <a:t>80</a:t>
+            </a:r>
+          </a:p>
+        </p:txBody>
+      </p:sp>
+      <p:sp>
+        <p:nvSpPr>
+          <p:cNvPr id="89" name="TextBox 88"/>
+          <p:cNvSpPr txBox="1"/>
+          <p:nvPr/>
+        </p:nvSpPr>
+        <p:spPr>
+          <a:xfrm>
+            <a:off x="685800" y="1967024"/>
             <a:ext cx="411480" cy="182880"/>
           </a:xfrm>
           <a:prstGeom prst="rect">
@@ -9629,20 +9734,20 @@
                 </a:solidFill>
                 <a:latin typeface="Calibri"/>
               </a:rPr>
-              <a:t>78</a:t>
-            </a:r>
-          </a:p>
-        </p:txBody>
-      </p:sp>
-      <p:sp>
-        <p:nvSpPr>
-          <p:cNvPr id="87" name="TextBox 86"/>
-          <p:cNvSpPr txBox="1"/>
-          <p:nvPr/>
-        </p:nvSpPr>
-        <p:spPr>
-          <a:xfrm>
-            <a:off x="685800" y="1918335"/>
+              <a:t>81</a:t>
+            </a:r>
+          </a:p>
+        </p:txBody>
+      </p:sp>
+      <p:sp>
+        <p:nvSpPr>
+          <p:cNvPr id="90" name="TextBox 89"/>
+          <p:cNvSpPr txBox="1"/>
+          <p:nvPr/>
+        </p:nvSpPr>
+        <p:spPr>
+          <a:xfrm>
+            <a:off x="685800" y="1954619"/>
             <a:ext cx="411480" cy="182880"/>
           </a:xfrm>
           <a:prstGeom prst="rect">
@@ -9664,14 +9769,119 @@
                 </a:solidFill>
                 <a:latin typeface="Calibri"/>
               </a:rPr>
-              <a:t>79</a:t>
-            </a:r>
-          </a:p>
-        </p:txBody>
-      </p:sp>
-      <p:sp>
-        <p:nvSpPr>
-          <p:cNvPr id="88" name="TextBox 87"/>
+              <a:t>82</a:t>
+            </a:r>
+          </a:p>
+        </p:txBody>
+      </p:sp>
+      <p:sp>
+        <p:nvSpPr>
+          <p:cNvPr id="91" name="TextBox 90"/>
+          <p:cNvSpPr txBox="1"/>
+          <p:nvPr/>
+        </p:nvSpPr>
+        <p:spPr>
+          <a:xfrm>
+            <a:off x="685800" y="1942214"/>
+            <a:ext cx="411480" cy="182880"/>
+          </a:xfrm>
+          <a:prstGeom prst="rect">
+            <a:avLst/>
+          </a:prstGeom>
+          <a:noFill/>
+        </p:spPr>
+        <p:txBody>
+          <a:bodyPr wrap="square" lIns="0" rIns="0" tIns="0" bIns="0">
+            <a:spAutoFit/>
+          </a:bodyPr>
+          <a:lstStyle/>
+          <a:p>
+            <a:pPr algn="r"/>
+            <a:r>
+              <a:rPr sz="900" b="0">
+                <a:solidFill>
+                  <a:srgbClr val="718096"/>
+                </a:solidFill>
+                <a:latin typeface="Calibri"/>
+              </a:rPr>
+              <a:t>83</a:t>
+            </a:r>
+          </a:p>
+        </p:txBody>
+      </p:sp>
+      <p:sp>
+        <p:nvSpPr>
+          <p:cNvPr id="92" name="TextBox 91"/>
+          <p:cNvSpPr txBox="1"/>
+          <p:nvPr/>
+        </p:nvSpPr>
+        <p:spPr>
+          <a:xfrm>
+            <a:off x="685800" y="1929810"/>
+            <a:ext cx="411480" cy="182880"/>
+          </a:xfrm>
+          <a:prstGeom prst="rect">
+            <a:avLst/>
+          </a:prstGeom>
+          <a:noFill/>
+        </p:spPr>
+        <p:txBody>
+          <a:bodyPr wrap="square" lIns="0" rIns="0" tIns="0" bIns="0">
+            <a:spAutoFit/>
+          </a:bodyPr>
+          <a:lstStyle/>
+          <a:p>
+            <a:pPr algn="r"/>
+            <a:r>
+              <a:rPr sz="900" b="0">
+                <a:solidFill>
+                  <a:srgbClr val="718096"/>
+                </a:solidFill>
+                <a:latin typeface="Calibri"/>
+              </a:rPr>
+              <a:t>84</a:t>
+            </a:r>
+          </a:p>
+        </p:txBody>
+      </p:sp>
+      <p:sp>
+        <p:nvSpPr>
+          <p:cNvPr id="93" name="TextBox 92"/>
+          <p:cNvSpPr txBox="1"/>
+          <p:nvPr/>
+        </p:nvSpPr>
+        <p:spPr>
+          <a:xfrm>
+            <a:off x="685800" y="1917405"/>
+            <a:ext cx="411480" cy="182880"/>
+          </a:xfrm>
+          <a:prstGeom prst="rect">
+            <a:avLst/>
+          </a:prstGeom>
+          <a:noFill/>
+        </p:spPr>
+        <p:txBody>
+          <a:bodyPr wrap="square" lIns="0" rIns="0" tIns="0" bIns="0">
+            <a:spAutoFit/>
+          </a:bodyPr>
+          <a:lstStyle/>
+          <a:p>
+            <a:pPr algn="r"/>
+            <a:r>
+              <a:rPr sz="900" b="0">
+                <a:solidFill>
+                  <a:srgbClr val="718096"/>
+                </a:solidFill>
+                <a:latin typeface="Calibri"/>
+              </a:rPr>
+              <a:t>85</a:t>
+            </a:r>
+          </a:p>
+        </p:txBody>
+      </p:sp>
+      <p:sp>
+        <p:nvSpPr>
+          <p:cNvPr id="94" name="TextBox 93"/>
           <p:cNvSpPr txBox="1"/>
           <p:nvPr/>
         </p:nvSpPr>
@@ -9699,20 +9909,20 @@
                 </a:solidFill>
                 <a:latin typeface="Calibri"/>
               </a:rPr>
-              <a:t>80</a:t>
-            </a:r>
-          </a:p>
-        </p:txBody>
-      </p:sp>
-      <p:sp>
-        <p:nvSpPr>
-          <p:cNvPr id="89" name="TextBox 88"/>
-          <p:cNvSpPr txBox="1"/>
-          <p:nvPr/>
-        </p:nvSpPr>
-        <p:spPr>
-          <a:xfrm>
-            <a:off x="685800" y="1891665"/>
+              <a:t>86</a:t>
+            </a:r>
+          </a:p>
+        </p:txBody>
+      </p:sp>
+      <p:sp>
+        <p:nvSpPr>
+          <p:cNvPr id="95" name="TextBox 94"/>
+          <p:cNvSpPr txBox="1"/>
+          <p:nvPr/>
+        </p:nvSpPr>
+        <p:spPr>
+          <a:xfrm>
+            <a:off x="685800" y="1892596"/>
             <a:ext cx="411480" cy="182880"/>
           </a:xfrm>
           <a:prstGeom prst="rect">
@@ -9734,20 +9944,20 @@
                 </a:solidFill>
                 <a:latin typeface="Calibri"/>
               </a:rPr>
-              <a:t>81</a:t>
-            </a:r>
-          </a:p>
-        </p:txBody>
-      </p:sp>
-      <p:sp>
-        <p:nvSpPr>
-          <p:cNvPr id="90" name="TextBox 89"/>
-          <p:cNvSpPr txBox="1"/>
-          <p:nvPr/>
-        </p:nvSpPr>
-        <p:spPr>
-          <a:xfrm>
-            <a:off x="685800" y="1878330"/>
+              <a:t>87</a:t>
+            </a:r>
+          </a:p>
+        </p:txBody>
+      </p:sp>
+      <p:sp>
+        <p:nvSpPr>
+          <p:cNvPr id="96" name="TextBox 95"/>
+          <p:cNvSpPr txBox="1"/>
+          <p:nvPr/>
+        </p:nvSpPr>
+        <p:spPr>
+          <a:xfrm>
+            <a:off x="685800" y="1880191"/>
             <a:ext cx="411480" cy="182880"/>
           </a:xfrm>
           <a:prstGeom prst="rect">
@@ -9769,20 +9979,20 @@
                 </a:solidFill>
                 <a:latin typeface="Calibri"/>
               </a:rPr>
-              <a:t>82</a:t>
-            </a:r>
-          </a:p>
-        </p:txBody>
-      </p:sp>
-      <p:sp>
-        <p:nvSpPr>
-          <p:cNvPr id="91" name="TextBox 90"/>
-          <p:cNvSpPr txBox="1"/>
-          <p:nvPr/>
-        </p:nvSpPr>
-        <p:spPr>
-          <a:xfrm>
-            <a:off x="685800" y="1864995"/>
+              <a:t>88</a:t>
+            </a:r>
+          </a:p>
+        </p:txBody>
+      </p:sp>
+      <p:sp>
+        <p:nvSpPr>
+          <p:cNvPr id="97" name="TextBox 96"/>
+          <p:cNvSpPr txBox="1"/>
+          <p:nvPr/>
+        </p:nvSpPr>
+        <p:spPr>
+          <a:xfrm>
+            <a:off x="685800" y="1867787"/>
             <a:ext cx="411480" cy="182880"/>
           </a:xfrm>
           <a:prstGeom prst="rect">
@@ -9804,20 +10014,20 @@
                 </a:solidFill>
                 <a:latin typeface="Calibri"/>
               </a:rPr>
-              <a:t>83</a:t>
-            </a:r>
-          </a:p>
-        </p:txBody>
-      </p:sp>
-      <p:sp>
-        <p:nvSpPr>
-          <p:cNvPr id="92" name="TextBox 91"/>
-          <p:cNvSpPr txBox="1"/>
-          <p:nvPr/>
-        </p:nvSpPr>
-        <p:spPr>
-          <a:xfrm>
-            <a:off x="685800" y="1851660"/>
+              <a:t>89</a:t>
+            </a:r>
+          </a:p>
+        </p:txBody>
+      </p:sp>
+      <p:sp>
+        <p:nvSpPr>
+          <p:cNvPr id="98" name="TextBox 97"/>
+          <p:cNvSpPr txBox="1"/>
+          <p:nvPr/>
+        </p:nvSpPr>
+        <p:spPr>
+          <a:xfrm>
+            <a:off x="685800" y="1855382"/>
             <a:ext cx="411480" cy="182880"/>
           </a:xfrm>
           <a:prstGeom prst="rect">
@@ -9839,20 +10049,20 @@
                 </a:solidFill>
                 <a:latin typeface="Calibri"/>
               </a:rPr>
-              <a:t>84</a:t>
-            </a:r>
-          </a:p>
-        </p:txBody>
-      </p:sp>
-      <p:sp>
-        <p:nvSpPr>
-          <p:cNvPr id="93" name="TextBox 92"/>
-          <p:cNvSpPr txBox="1"/>
-          <p:nvPr/>
-        </p:nvSpPr>
-        <p:spPr>
-          <a:xfrm>
-            <a:off x="685800" y="1838325"/>
+              <a:t>90</a:t>
+            </a:r>
+          </a:p>
+        </p:txBody>
+      </p:sp>
+      <p:sp>
+        <p:nvSpPr>
+          <p:cNvPr id="99" name="TextBox 98"/>
+          <p:cNvSpPr txBox="1"/>
+          <p:nvPr/>
+        </p:nvSpPr>
+        <p:spPr>
+          <a:xfrm>
+            <a:off x="685800" y="1842977"/>
             <a:ext cx="411480" cy="182880"/>
           </a:xfrm>
           <a:prstGeom prst="rect">
@@ -9874,20 +10084,20 @@
                 </a:solidFill>
                 <a:latin typeface="Calibri"/>
               </a:rPr>
-              <a:t>85</a:t>
-            </a:r>
-          </a:p>
-        </p:txBody>
-      </p:sp>
-      <p:sp>
-        <p:nvSpPr>
-          <p:cNvPr id="94" name="TextBox 93"/>
-          <p:cNvSpPr txBox="1"/>
-          <p:nvPr/>
-        </p:nvSpPr>
-        <p:spPr>
-          <a:xfrm>
-            <a:off x="685800" y="1824990"/>
+              <a:t>91</a:t>
+            </a:r>
+          </a:p>
+        </p:txBody>
+      </p:sp>
+      <p:sp>
+        <p:nvSpPr>
+          <p:cNvPr id="100" name="TextBox 99"/>
+          <p:cNvSpPr txBox="1"/>
+          <p:nvPr/>
+        </p:nvSpPr>
+        <p:spPr>
+          <a:xfrm>
+            <a:off x="685800" y="1830573"/>
             <a:ext cx="411480" cy="182880"/>
           </a:xfrm>
           <a:prstGeom prst="rect">
@@ -9909,20 +10119,20 @@
                 </a:solidFill>
                 <a:latin typeface="Calibri"/>
               </a:rPr>
-              <a:t>86</a:t>
-            </a:r>
-          </a:p>
-        </p:txBody>
-      </p:sp>
-      <p:sp>
-        <p:nvSpPr>
-          <p:cNvPr id="95" name="TextBox 94"/>
-          <p:cNvSpPr txBox="1"/>
-          <p:nvPr/>
-        </p:nvSpPr>
-        <p:spPr>
-          <a:xfrm>
-            <a:off x="685800" y="1811655"/>
+              <a:t>92</a:t>
+            </a:r>
+          </a:p>
+        </p:txBody>
+      </p:sp>
+      <p:sp>
+        <p:nvSpPr>
+          <p:cNvPr id="101" name="TextBox 100"/>
+          <p:cNvSpPr txBox="1"/>
+          <p:nvPr/>
+        </p:nvSpPr>
+        <p:spPr>
+          <a:xfrm>
+            <a:off x="685800" y="1818168"/>
             <a:ext cx="411480" cy="182880"/>
           </a:xfrm>
           <a:prstGeom prst="rect">
@@ -9944,20 +10154,20 @@
                 </a:solidFill>
                 <a:latin typeface="Calibri"/>
               </a:rPr>
-              <a:t>87</a:t>
-            </a:r>
-          </a:p>
-        </p:txBody>
-      </p:sp>
-      <p:sp>
-        <p:nvSpPr>
-          <p:cNvPr id="96" name="TextBox 95"/>
-          <p:cNvSpPr txBox="1"/>
-          <p:nvPr/>
-        </p:nvSpPr>
-        <p:spPr>
-          <a:xfrm>
-            <a:off x="685800" y="1798320"/>
+              <a:t>93</a:t>
+            </a:r>
+          </a:p>
+        </p:txBody>
+      </p:sp>
+      <p:sp>
+        <p:nvSpPr>
+          <p:cNvPr id="102" name="TextBox 101"/>
+          <p:cNvSpPr txBox="1"/>
+          <p:nvPr/>
+        </p:nvSpPr>
+        <p:spPr>
+          <a:xfrm>
+            <a:off x="685800" y="1805763"/>
             <a:ext cx="411480" cy="182880"/>
           </a:xfrm>
           <a:prstGeom prst="rect">
@@ -9979,20 +10189,20 @@
                 </a:solidFill>
                 <a:latin typeface="Calibri"/>
               </a:rPr>
-              <a:t>88</a:t>
-            </a:r>
-          </a:p>
-        </p:txBody>
-      </p:sp>
-      <p:sp>
-        <p:nvSpPr>
-          <p:cNvPr id="97" name="TextBox 96"/>
-          <p:cNvSpPr txBox="1"/>
-          <p:nvPr/>
-        </p:nvSpPr>
-        <p:spPr>
-          <a:xfrm>
-            <a:off x="685800" y="1784985"/>
+              <a:t>94</a:t>
+            </a:r>
+          </a:p>
+        </p:txBody>
+      </p:sp>
+      <p:sp>
+        <p:nvSpPr>
+          <p:cNvPr id="103" name="TextBox 102"/>
+          <p:cNvSpPr txBox="1"/>
+          <p:nvPr/>
+        </p:nvSpPr>
+        <p:spPr>
+          <a:xfrm>
+            <a:off x="685800" y="1793359"/>
             <a:ext cx="411480" cy="182880"/>
           </a:xfrm>
           <a:prstGeom prst="rect">
@@ -10014,20 +10224,20 @@
                 </a:solidFill>
                 <a:latin typeface="Calibri"/>
               </a:rPr>
-              <a:t>89</a:t>
-            </a:r>
-          </a:p>
-        </p:txBody>
-      </p:sp>
-      <p:sp>
-        <p:nvSpPr>
-          <p:cNvPr id="98" name="TextBox 97"/>
-          <p:cNvSpPr txBox="1"/>
-          <p:nvPr/>
-        </p:nvSpPr>
-        <p:spPr>
-          <a:xfrm>
-            <a:off x="685800" y="1771650"/>
+              <a:t>95</a:t>
+            </a:r>
+          </a:p>
+        </p:txBody>
+      </p:sp>
+      <p:sp>
+        <p:nvSpPr>
+          <p:cNvPr id="104" name="TextBox 103"/>
+          <p:cNvSpPr txBox="1"/>
+          <p:nvPr/>
+        </p:nvSpPr>
+        <p:spPr>
+          <a:xfrm>
+            <a:off x="685800" y="1780954"/>
             <a:ext cx="411480" cy="182880"/>
           </a:xfrm>
           <a:prstGeom prst="rect">
@@ -10049,20 +10259,20 @@
                 </a:solidFill>
                 <a:latin typeface="Calibri"/>
               </a:rPr>
-              <a:t>90</a:t>
-            </a:r>
-          </a:p>
-        </p:txBody>
-      </p:sp>
-      <p:sp>
-        <p:nvSpPr>
-          <p:cNvPr id="99" name="TextBox 98"/>
-          <p:cNvSpPr txBox="1"/>
-          <p:nvPr/>
-        </p:nvSpPr>
-        <p:spPr>
-          <a:xfrm>
-            <a:off x="685800" y="1758315"/>
+              <a:t>96</a:t>
+            </a:r>
+          </a:p>
+        </p:txBody>
+      </p:sp>
+      <p:sp>
+        <p:nvSpPr>
+          <p:cNvPr id="105" name="TextBox 104"/>
+          <p:cNvSpPr txBox="1"/>
+          <p:nvPr/>
+        </p:nvSpPr>
+        <p:spPr>
+          <a:xfrm>
+            <a:off x="685800" y="1768549"/>
             <a:ext cx="411480" cy="182880"/>
           </a:xfrm>
           <a:prstGeom prst="rect">
@@ -10084,20 +10294,20 @@
                 </a:solidFill>
                 <a:latin typeface="Calibri"/>
               </a:rPr>
-              <a:t>91</a:t>
-            </a:r>
-          </a:p>
-        </p:txBody>
-      </p:sp>
-      <p:sp>
-        <p:nvSpPr>
-          <p:cNvPr id="100" name="TextBox 99"/>
-          <p:cNvSpPr txBox="1"/>
-          <p:nvPr/>
-        </p:nvSpPr>
-        <p:spPr>
-          <a:xfrm>
-            <a:off x="685800" y="1744980"/>
+              <a:t>97</a:t>
+            </a:r>
+          </a:p>
+        </p:txBody>
+      </p:sp>
+      <p:sp>
+        <p:nvSpPr>
+          <p:cNvPr id="106" name="TextBox 105"/>
+          <p:cNvSpPr txBox="1"/>
+          <p:nvPr/>
+        </p:nvSpPr>
+        <p:spPr>
+          <a:xfrm>
+            <a:off x="685800" y="1756145"/>
             <a:ext cx="411480" cy="182880"/>
           </a:xfrm>
           <a:prstGeom prst="rect">
@@ -10119,20 +10329,20 @@
                 </a:solidFill>
                 <a:latin typeface="Calibri"/>
               </a:rPr>
-              <a:t>92</a:t>
-            </a:r>
-          </a:p>
-        </p:txBody>
-      </p:sp>
-      <p:sp>
-        <p:nvSpPr>
-          <p:cNvPr id="101" name="TextBox 100"/>
-          <p:cNvSpPr txBox="1"/>
-          <p:nvPr/>
-        </p:nvSpPr>
-        <p:spPr>
-          <a:xfrm>
-            <a:off x="685800" y="1731645"/>
+              <a:t>98</a:t>
+            </a:r>
+          </a:p>
+        </p:txBody>
+      </p:sp>
+      <p:sp>
+        <p:nvSpPr>
+          <p:cNvPr id="107" name="TextBox 106"/>
+          <p:cNvSpPr txBox="1"/>
+          <p:nvPr/>
+        </p:nvSpPr>
+        <p:spPr>
+          <a:xfrm>
+            <a:off x="685800" y="1743740"/>
             <a:ext cx="411480" cy="182880"/>
           </a:xfrm>
           <a:prstGeom prst="rect">
@@ -10154,20 +10364,20 @@
                 </a:solidFill>
                 <a:latin typeface="Calibri"/>
               </a:rPr>
-              <a:t>93</a:t>
-            </a:r>
-          </a:p>
-        </p:txBody>
-      </p:sp>
-      <p:sp>
-        <p:nvSpPr>
-          <p:cNvPr id="102" name="TextBox 101"/>
-          <p:cNvSpPr txBox="1"/>
-          <p:nvPr/>
-        </p:nvSpPr>
-        <p:spPr>
-          <a:xfrm>
-            <a:off x="685800" y="1718310"/>
+              <a:t>99</a:t>
+            </a:r>
+          </a:p>
+        </p:txBody>
+      </p:sp>
+      <p:sp>
+        <p:nvSpPr>
+          <p:cNvPr id="108" name="TextBox 107"/>
+          <p:cNvSpPr txBox="1"/>
+          <p:nvPr/>
+        </p:nvSpPr>
+        <p:spPr>
+          <a:xfrm>
+            <a:off x="685800" y="1731335"/>
             <a:ext cx="411480" cy="182880"/>
           </a:xfrm>
           <a:prstGeom prst="rect">
@@ -10189,20 +10399,20 @@
                 </a:solidFill>
                 <a:latin typeface="Calibri"/>
               </a:rPr>
-              <a:t>94</a:t>
-            </a:r>
-          </a:p>
-        </p:txBody>
-      </p:sp>
-      <p:sp>
-        <p:nvSpPr>
-          <p:cNvPr id="103" name="TextBox 102"/>
-          <p:cNvSpPr txBox="1"/>
-          <p:nvPr/>
-        </p:nvSpPr>
-        <p:spPr>
-          <a:xfrm>
-            <a:off x="685800" y="1704975"/>
+              <a:t>100</a:t>
+            </a:r>
+          </a:p>
+        </p:txBody>
+      </p:sp>
+      <p:sp>
+        <p:nvSpPr>
+          <p:cNvPr id="109" name="TextBox 108"/>
+          <p:cNvSpPr txBox="1"/>
+          <p:nvPr/>
+        </p:nvSpPr>
+        <p:spPr>
+          <a:xfrm>
+            <a:off x="685800" y="1718931"/>
             <a:ext cx="411480" cy="182880"/>
           </a:xfrm>
           <a:prstGeom prst="rect">
@@ -10224,20 +10434,20 @@
                 </a:solidFill>
                 <a:latin typeface="Calibri"/>
               </a:rPr>
-              <a:t>95</a:t>
-            </a:r>
-          </a:p>
-        </p:txBody>
-      </p:sp>
-      <p:sp>
-        <p:nvSpPr>
-          <p:cNvPr id="104" name="TextBox 103"/>
-          <p:cNvSpPr txBox="1"/>
-          <p:nvPr/>
-        </p:nvSpPr>
-        <p:spPr>
-          <a:xfrm>
-            <a:off x="685800" y="1691640"/>
+              <a:t>101</a:t>
+            </a:r>
+          </a:p>
+        </p:txBody>
+      </p:sp>
+      <p:sp>
+        <p:nvSpPr>
+          <p:cNvPr id="110" name="TextBox 109"/>
+          <p:cNvSpPr txBox="1"/>
+          <p:nvPr/>
+        </p:nvSpPr>
+        <p:spPr>
+          <a:xfrm>
+            <a:off x="685800" y="1706526"/>
             <a:ext cx="411480" cy="182880"/>
           </a:xfrm>
           <a:prstGeom prst="rect">
@@ -10259,20 +10469,20 @@
                 </a:solidFill>
                 <a:latin typeface="Calibri"/>
               </a:rPr>
-              <a:t>96</a:t>
-            </a:r>
-          </a:p>
-        </p:txBody>
-      </p:sp>
-      <p:sp>
-        <p:nvSpPr>
-          <p:cNvPr id="105" name="TextBox 104"/>
-          <p:cNvSpPr txBox="1"/>
-          <p:nvPr/>
-        </p:nvSpPr>
-        <p:spPr>
-          <a:xfrm>
-            <a:off x="685800" y="1678305"/>
+              <a:t>102</a:t>
+            </a:r>
+          </a:p>
+        </p:txBody>
+      </p:sp>
+      <p:sp>
+        <p:nvSpPr>
+          <p:cNvPr id="111" name="TextBox 110"/>
+          <p:cNvSpPr txBox="1"/>
+          <p:nvPr/>
+        </p:nvSpPr>
+        <p:spPr>
+          <a:xfrm>
+            <a:off x="685800" y="1694121"/>
             <a:ext cx="411480" cy="182880"/>
           </a:xfrm>
           <a:prstGeom prst="rect">
@@ -10294,20 +10504,20 @@
                 </a:solidFill>
                 <a:latin typeface="Calibri"/>
               </a:rPr>
-              <a:t>97</a:t>
-            </a:r>
-          </a:p>
-        </p:txBody>
-      </p:sp>
-      <p:sp>
-        <p:nvSpPr>
-          <p:cNvPr id="106" name="TextBox 105"/>
-          <p:cNvSpPr txBox="1"/>
-          <p:nvPr/>
-        </p:nvSpPr>
-        <p:spPr>
-          <a:xfrm>
-            <a:off x="685800" y="1664970"/>
+              <a:t>103</a:t>
+            </a:r>
+          </a:p>
+        </p:txBody>
+      </p:sp>
+      <p:sp>
+        <p:nvSpPr>
+          <p:cNvPr id="112" name="TextBox 111"/>
+          <p:cNvSpPr txBox="1"/>
+          <p:nvPr/>
+        </p:nvSpPr>
+        <p:spPr>
+          <a:xfrm>
+            <a:off x="685800" y="1681717"/>
             <a:ext cx="411480" cy="182880"/>
           </a:xfrm>
           <a:prstGeom prst="rect">
@@ -10329,20 +10539,20 @@
                 </a:solidFill>
                 <a:latin typeface="Calibri"/>
               </a:rPr>
-              <a:t>98</a:t>
-            </a:r>
-          </a:p>
-        </p:txBody>
-      </p:sp>
-      <p:sp>
-        <p:nvSpPr>
-          <p:cNvPr id="107" name="TextBox 106"/>
-          <p:cNvSpPr txBox="1"/>
-          <p:nvPr/>
-        </p:nvSpPr>
-        <p:spPr>
-          <a:xfrm>
-            <a:off x="685800" y="1651635"/>
+              <a:t>104</a:t>
+            </a:r>
+          </a:p>
+        </p:txBody>
+      </p:sp>
+      <p:sp>
+        <p:nvSpPr>
+          <p:cNvPr id="113" name="TextBox 112"/>
+          <p:cNvSpPr txBox="1"/>
+          <p:nvPr/>
+        </p:nvSpPr>
+        <p:spPr>
+          <a:xfrm>
+            <a:off x="685800" y="1669312"/>
             <a:ext cx="411480" cy="182880"/>
           </a:xfrm>
           <a:prstGeom prst="rect">
@@ -10364,20 +10574,20 @@
                 </a:solidFill>
                 <a:latin typeface="Calibri"/>
               </a:rPr>
-              <a:t>99</a:t>
-            </a:r>
-          </a:p>
-        </p:txBody>
-      </p:sp>
-      <p:sp>
-        <p:nvSpPr>
-          <p:cNvPr id="108" name="TextBox 107"/>
-          <p:cNvSpPr txBox="1"/>
-          <p:nvPr/>
-        </p:nvSpPr>
-        <p:spPr>
-          <a:xfrm>
-            <a:off x="685800" y="1638300"/>
+              <a:t>105</a:t>
+            </a:r>
+          </a:p>
+        </p:txBody>
+      </p:sp>
+      <p:sp>
+        <p:nvSpPr>
+          <p:cNvPr id="114" name="TextBox 113"/>
+          <p:cNvSpPr txBox="1"/>
+          <p:nvPr/>
+        </p:nvSpPr>
+        <p:spPr>
+          <a:xfrm>
+            <a:off x="685800" y="1656907"/>
             <a:ext cx="411480" cy="182880"/>
           </a:xfrm>
           <a:prstGeom prst="rect">
@@ -10399,20 +10609,20 @@
                 </a:solidFill>
                 <a:latin typeface="Calibri"/>
               </a:rPr>
-              <a:t>100</a:t>
-            </a:r>
-          </a:p>
-        </p:txBody>
-      </p:sp>
-      <p:sp>
-        <p:nvSpPr>
-          <p:cNvPr id="109" name="TextBox 108"/>
-          <p:cNvSpPr txBox="1"/>
-          <p:nvPr/>
-        </p:nvSpPr>
-        <p:spPr>
-          <a:xfrm>
-            <a:off x="685800" y="1624965"/>
+              <a:t>106</a:t>
+            </a:r>
+          </a:p>
+        </p:txBody>
+      </p:sp>
+      <p:sp>
+        <p:nvSpPr>
+          <p:cNvPr id="115" name="TextBox 114"/>
+          <p:cNvSpPr txBox="1"/>
+          <p:nvPr/>
+        </p:nvSpPr>
+        <p:spPr>
+          <a:xfrm>
+            <a:off x="685800" y="1644503"/>
             <a:ext cx="411480" cy="182880"/>
           </a:xfrm>
           <a:prstGeom prst="rect">
@@ -10434,20 +10644,20 @@
                 </a:solidFill>
                 <a:latin typeface="Calibri"/>
               </a:rPr>
-              <a:t>101</a:t>
-            </a:r>
-          </a:p>
-        </p:txBody>
-      </p:sp>
-      <p:sp>
-        <p:nvSpPr>
-          <p:cNvPr id="110" name="TextBox 109"/>
-          <p:cNvSpPr txBox="1"/>
-          <p:nvPr/>
-        </p:nvSpPr>
-        <p:spPr>
-          <a:xfrm>
-            <a:off x="685800" y="1611630"/>
+              <a:t>107</a:t>
+            </a:r>
+          </a:p>
+        </p:txBody>
+      </p:sp>
+      <p:sp>
+        <p:nvSpPr>
+          <p:cNvPr id="116" name="TextBox 115"/>
+          <p:cNvSpPr txBox="1"/>
+          <p:nvPr/>
+        </p:nvSpPr>
+        <p:spPr>
+          <a:xfrm>
+            <a:off x="685800" y="1632098"/>
             <a:ext cx="411480" cy="182880"/>
           </a:xfrm>
           <a:prstGeom prst="rect">
@@ -10469,20 +10679,20 @@
                 </a:solidFill>
                 <a:latin typeface="Calibri"/>
               </a:rPr>
-              <a:t>102</a:t>
-            </a:r>
-          </a:p>
-        </p:txBody>
-      </p:sp>
-      <p:sp>
-        <p:nvSpPr>
-          <p:cNvPr id="111" name="TextBox 110"/>
-          <p:cNvSpPr txBox="1"/>
-          <p:nvPr/>
-        </p:nvSpPr>
-        <p:spPr>
-          <a:xfrm>
-            <a:off x="685800" y="1598295"/>
+              <a:t>108</a:t>
+            </a:r>
+          </a:p>
+        </p:txBody>
+      </p:sp>
+      <p:sp>
+        <p:nvSpPr>
+          <p:cNvPr id="117" name="TextBox 116"/>
+          <p:cNvSpPr txBox="1"/>
+          <p:nvPr/>
+        </p:nvSpPr>
+        <p:spPr>
+          <a:xfrm>
+            <a:off x="685800" y="1619694"/>
             <a:ext cx="411480" cy="182880"/>
           </a:xfrm>
           <a:prstGeom prst="rect">
@@ -10504,20 +10714,20 @@
                 </a:solidFill>
                 <a:latin typeface="Calibri"/>
               </a:rPr>
-              <a:t>103</a:t>
-            </a:r>
-          </a:p>
-        </p:txBody>
-      </p:sp>
-      <p:sp>
-        <p:nvSpPr>
-          <p:cNvPr id="112" name="TextBox 111"/>
-          <p:cNvSpPr txBox="1"/>
-          <p:nvPr/>
-        </p:nvSpPr>
-        <p:spPr>
-          <a:xfrm>
-            <a:off x="685800" y="1584960"/>
+              <a:t>109</a:t>
+            </a:r>
+          </a:p>
+        </p:txBody>
+      </p:sp>
+      <p:sp>
+        <p:nvSpPr>
+          <p:cNvPr id="118" name="TextBox 117"/>
+          <p:cNvSpPr txBox="1"/>
+          <p:nvPr/>
+        </p:nvSpPr>
+        <p:spPr>
+          <a:xfrm>
+            <a:off x="685800" y="1607289"/>
             <a:ext cx="411480" cy="182880"/>
           </a:xfrm>
           <a:prstGeom prst="rect">
@@ -10539,20 +10749,20 @@
                 </a:solidFill>
                 <a:latin typeface="Calibri"/>
               </a:rPr>
-              <a:t>104</a:t>
-            </a:r>
-          </a:p>
-        </p:txBody>
-      </p:sp>
-      <p:sp>
-        <p:nvSpPr>
-          <p:cNvPr id="113" name="TextBox 112"/>
-          <p:cNvSpPr txBox="1"/>
-          <p:nvPr/>
-        </p:nvSpPr>
-        <p:spPr>
-          <a:xfrm>
-            <a:off x="685800" y="1571625"/>
+              <a:t>110</a:t>
+            </a:r>
+          </a:p>
+        </p:txBody>
+      </p:sp>
+      <p:sp>
+        <p:nvSpPr>
+          <p:cNvPr id="119" name="TextBox 118"/>
+          <p:cNvSpPr txBox="1"/>
+          <p:nvPr/>
+        </p:nvSpPr>
+        <p:spPr>
+          <a:xfrm>
+            <a:off x="685800" y="1594884"/>
             <a:ext cx="411480" cy="182880"/>
           </a:xfrm>
           <a:prstGeom prst="rect">
@@ -10574,20 +10784,20 @@
                 </a:solidFill>
                 <a:latin typeface="Calibri"/>
               </a:rPr>
-              <a:t>105</a:t>
-            </a:r>
-          </a:p>
-        </p:txBody>
-      </p:sp>
-      <p:sp>
-        <p:nvSpPr>
-          <p:cNvPr id="114" name="TextBox 113"/>
-          <p:cNvSpPr txBox="1"/>
-          <p:nvPr/>
-        </p:nvSpPr>
-        <p:spPr>
-          <a:xfrm>
-            <a:off x="685800" y="1558290"/>
+              <a:t>111</a:t>
+            </a:r>
+          </a:p>
+        </p:txBody>
+      </p:sp>
+      <p:sp>
+        <p:nvSpPr>
+          <p:cNvPr id="120" name="TextBox 119"/>
+          <p:cNvSpPr txBox="1"/>
+          <p:nvPr/>
+        </p:nvSpPr>
+        <p:spPr>
+          <a:xfrm>
+            <a:off x="685800" y="1582480"/>
             <a:ext cx="411480" cy="182880"/>
           </a:xfrm>
           <a:prstGeom prst="rect">
@@ -10609,20 +10819,20 @@
                 </a:solidFill>
                 <a:latin typeface="Calibri"/>
               </a:rPr>
-              <a:t>106</a:t>
-            </a:r>
-          </a:p>
-        </p:txBody>
-      </p:sp>
-      <p:sp>
-        <p:nvSpPr>
-          <p:cNvPr id="115" name="TextBox 114"/>
-          <p:cNvSpPr txBox="1"/>
-          <p:nvPr/>
-        </p:nvSpPr>
-        <p:spPr>
-          <a:xfrm>
-            <a:off x="685800" y="1544955"/>
+              <a:t>112</a:t>
+            </a:r>
+          </a:p>
+        </p:txBody>
+      </p:sp>
+      <p:sp>
+        <p:nvSpPr>
+          <p:cNvPr id="121" name="TextBox 120"/>
+          <p:cNvSpPr txBox="1"/>
+          <p:nvPr/>
+        </p:nvSpPr>
+        <p:spPr>
+          <a:xfrm>
+            <a:off x="685800" y="1570075"/>
             <a:ext cx="411480" cy="182880"/>
           </a:xfrm>
           <a:prstGeom prst="rect">
@@ -10644,20 +10854,20 @@
                 </a:solidFill>
                 <a:latin typeface="Calibri"/>
               </a:rPr>
-              <a:t>107</a:t>
-            </a:r>
-          </a:p>
-        </p:txBody>
-      </p:sp>
-      <p:sp>
-        <p:nvSpPr>
-          <p:cNvPr id="116" name="TextBox 115"/>
-          <p:cNvSpPr txBox="1"/>
-          <p:nvPr/>
-        </p:nvSpPr>
-        <p:spPr>
-          <a:xfrm>
-            <a:off x="685800" y="1531620"/>
+              <a:t>113</a:t>
+            </a:r>
+          </a:p>
+        </p:txBody>
+      </p:sp>
+      <p:sp>
+        <p:nvSpPr>
+          <p:cNvPr id="122" name="TextBox 121"/>
+          <p:cNvSpPr txBox="1"/>
+          <p:nvPr/>
+        </p:nvSpPr>
+        <p:spPr>
+          <a:xfrm>
+            <a:off x="685800" y="1557670"/>
             <a:ext cx="411480" cy="182880"/>
           </a:xfrm>
           <a:prstGeom prst="rect">
@@ -10679,20 +10889,20 @@
                 </a:solidFill>
                 <a:latin typeface="Calibri"/>
               </a:rPr>
-              <a:t>108</a:t>
-            </a:r>
-          </a:p>
-        </p:txBody>
-      </p:sp>
-      <p:sp>
-        <p:nvSpPr>
-          <p:cNvPr id="117" name="TextBox 116"/>
-          <p:cNvSpPr txBox="1"/>
-          <p:nvPr/>
-        </p:nvSpPr>
-        <p:spPr>
-          <a:xfrm>
-            <a:off x="685800" y="1518285"/>
+              <a:t>114</a:t>
+            </a:r>
+          </a:p>
+        </p:txBody>
+      </p:sp>
+      <p:sp>
+        <p:nvSpPr>
+          <p:cNvPr id="123" name="TextBox 122"/>
+          <p:cNvSpPr txBox="1"/>
+          <p:nvPr/>
+        </p:nvSpPr>
+        <p:spPr>
+          <a:xfrm>
+            <a:off x="685800" y="1545266"/>
             <a:ext cx="411480" cy="182880"/>
           </a:xfrm>
           <a:prstGeom prst="rect">
@@ -10714,20 +10924,20 @@
                 </a:solidFill>
                 <a:latin typeface="Calibri"/>
               </a:rPr>
-              <a:t>109</a:t>
-            </a:r>
-          </a:p>
-        </p:txBody>
-      </p:sp>
-      <p:sp>
-        <p:nvSpPr>
-          <p:cNvPr id="118" name="TextBox 117"/>
-          <p:cNvSpPr txBox="1"/>
-          <p:nvPr/>
-        </p:nvSpPr>
-        <p:spPr>
-          <a:xfrm>
-            <a:off x="685800" y="1504950"/>
+              <a:t>115</a:t>
+            </a:r>
+          </a:p>
+        </p:txBody>
+      </p:sp>
+      <p:sp>
+        <p:nvSpPr>
+          <p:cNvPr id="124" name="TextBox 123"/>
+          <p:cNvSpPr txBox="1"/>
+          <p:nvPr/>
+        </p:nvSpPr>
+        <p:spPr>
+          <a:xfrm>
+            <a:off x="685800" y="1532861"/>
             <a:ext cx="411480" cy="182880"/>
           </a:xfrm>
           <a:prstGeom prst="rect">
@@ -10749,20 +10959,20 @@
                 </a:solidFill>
                 <a:latin typeface="Calibri"/>
               </a:rPr>
-              <a:t>110</a:t>
-            </a:r>
-          </a:p>
-        </p:txBody>
-      </p:sp>
-      <p:sp>
-        <p:nvSpPr>
-          <p:cNvPr id="119" name="TextBox 118"/>
-          <p:cNvSpPr txBox="1"/>
-          <p:nvPr/>
-        </p:nvSpPr>
-        <p:spPr>
-          <a:xfrm>
-            <a:off x="685800" y="1491615"/>
+              <a:t>116</a:t>
+            </a:r>
+          </a:p>
+        </p:txBody>
+      </p:sp>
+      <p:sp>
+        <p:nvSpPr>
+          <p:cNvPr id="125" name="TextBox 124"/>
+          <p:cNvSpPr txBox="1"/>
+          <p:nvPr/>
+        </p:nvSpPr>
+        <p:spPr>
+          <a:xfrm>
+            <a:off x="685800" y="1520456"/>
             <a:ext cx="411480" cy="182880"/>
           </a:xfrm>
           <a:prstGeom prst="rect">
@@ -10784,20 +10994,20 @@
                 </a:solidFill>
                 <a:latin typeface="Calibri"/>
               </a:rPr>
-              <a:t>111</a:t>
-            </a:r>
-          </a:p>
-        </p:txBody>
-      </p:sp>
-      <p:sp>
-        <p:nvSpPr>
-          <p:cNvPr id="120" name="TextBox 119"/>
-          <p:cNvSpPr txBox="1"/>
-          <p:nvPr/>
-        </p:nvSpPr>
-        <p:spPr>
-          <a:xfrm>
-            <a:off x="685800" y="1478280"/>
+              <a:t>117</a:t>
+            </a:r>
+          </a:p>
+        </p:txBody>
+      </p:sp>
+      <p:sp>
+        <p:nvSpPr>
+          <p:cNvPr id="126" name="TextBox 125"/>
+          <p:cNvSpPr txBox="1"/>
+          <p:nvPr/>
+        </p:nvSpPr>
+        <p:spPr>
+          <a:xfrm>
+            <a:off x="685800" y="1508052"/>
             <a:ext cx="411480" cy="182880"/>
           </a:xfrm>
           <a:prstGeom prst="rect">
@@ -10819,20 +11029,20 @@
                 </a:solidFill>
                 <a:latin typeface="Calibri"/>
               </a:rPr>
-              <a:t>112</a:t>
-            </a:r>
-          </a:p>
-        </p:txBody>
-      </p:sp>
-      <p:sp>
-        <p:nvSpPr>
-          <p:cNvPr id="121" name="TextBox 120"/>
-          <p:cNvSpPr txBox="1"/>
-          <p:nvPr/>
-        </p:nvSpPr>
-        <p:spPr>
-          <a:xfrm>
-            <a:off x="685800" y="1464945"/>
+              <a:t>118</a:t>
+            </a:r>
+          </a:p>
+        </p:txBody>
+      </p:sp>
+      <p:sp>
+        <p:nvSpPr>
+          <p:cNvPr id="127" name="TextBox 126"/>
+          <p:cNvSpPr txBox="1"/>
+          <p:nvPr/>
+        </p:nvSpPr>
+        <p:spPr>
+          <a:xfrm>
+            <a:off x="685800" y="1495647"/>
             <a:ext cx="411480" cy="182880"/>
           </a:xfrm>
           <a:prstGeom prst="rect">
@@ -10854,20 +11064,20 @@
                 </a:solidFill>
                 <a:latin typeface="Calibri"/>
               </a:rPr>
-              <a:t>113</a:t>
-            </a:r>
-          </a:p>
-        </p:txBody>
-      </p:sp>
-      <p:sp>
-        <p:nvSpPr>
-          <p:cNvPr id="122" name="TextBox 121"/>
-          <p:cNvSpPr txBox="1"/>
-          <p:nvPr/>
-        </p:nvSpPr>
-        <p:spPr>
-          <a:xfrm>
-            <a:off x="685800" y="1451610"/>
+              <a:t>119</a:t>
+            </a:r>
+          </a:p>
+        </p:txBody>
+      </p:sp>
+      <p:sp>
+        <p:nvSpPr>
+          <p:cNvPr id="128" name="TextBox 127"/>
+          <p:cNvSpPr txBox="1"/>
+          <p:nvPr/>
+        </p:nvSpPr>
+        <p:spPr>
+          <a:xfrm>
+            <a:off x="685800" y="1483242"/>
             <a:ext cx="411480" cy="182880"/>
           </a:xfrm>
           <a:prstGeom prst="rect">
@@ -10889,20 +11099,20 @@
                 </a:solidFill>
                 <a:latin typeface="Calibri"/>
               </a:rPr>
-              <a:t>114</a:t>
-            </a:r>
-          </a:p>
-        </p:txBody>
-      </p:sp>
-      <p:sp>
-        <p:nvSpPr>
-          <p:cNvPr id="123" name="TextBox 122"/>
-          <p:cNvSpPr txBox="1"/>
-          <p:nvPr/>
-        </p:nvSpPr>
-        <p:spPr>
-          <a:xfrm>
-            <a:off x="685800" y="1438275"/>
+              <a:t>120</a:t>
+            </a:r>
+          </a:p>
+        </p:txBody>
+      </p:sp>
+      <p:sp>
+        <p:nvSpPr>
+          <p:cNvPr id="129" name="TextBox 128"/>
+          <p:cNvSpPr txBox="1"/>
+          <p:nvPr/>
+        </p:nvSpPr>
+        <p:spPr>
+          <a:xfrm>
+            <a:off x="685800" y="1470838"/>
             <a:ext cx="411480" cy="182880"/>
           </a:xfrm>
           <a:prstGeom prst="rect">
@@ -10924,20 +11134,20 @@
                 </a:solidFill>
                 <a:latin typeface="Calibri"/>
               </a:rPr>
-              <a:t>115</a:t>
-            </a:r>
-          </a:p>
-        </p:txBody>
-      </p:sp>
-      <p:sp>
-        <p:nvSpPr>
-          <p:cNvPr id="124" name="TextBox 123"/>
-          <p:cNvSpPr txBox="1"/>
-          <p:nvPr/>
-        </p:nvSpPr>
-        <p:spPr>
-          <a:xfrm>
-            <a:off x="685800" y="1424940"/>
+              <a:t>121</a:t>
+            </a:r>
+          </a:p>
+        </p:txBody>
+      </p:sp>
+      <p:sp>
+        <p:nvSpPr>
+          <p:cNvPr id="130" name="TextBox 129"/>
+          <p:cNvSpPr txBox="1"/>
+          <p:nvPr/>
+        </p:nvSpPr>
+        <p:spPr>
+          <a:xfrm>
+            <a:off x="685800" y="1458433"/>
             <a:ext cx="411480" cy="182880"/>
           </a:xfrm>
           <a:prstGeom prst="rect">
@@ -10959,20 +11169,20 @@
                 </a:solidFill>
                 <a:latin typeface="Calibri"/>
               </a:rPr>
-              <a:t>116</a:t>
-            </a:r>
-          </a:p>
-        </p:txBody>
-      </p:sp>
-      <p:sp>
-        <p:nvSpPr>
-          <p:cNvPr id="125" name="TextBox 124"/>
-          <p:cNvSpPr txBox="1"/>
-          <p:nvPr/>
-        </p:nvSpPr>
-        <p:spPr>
-          <a:xfrm>
-            <a:off x="685800" y="1411605"/>
+              <a:t>122</a:t>
+            </a:r>
+          </a:p>
+        </p:txBody>
+      </p:sp>
+      <p:sp>
+        <p:nvSpPr>
+          <p:cNvPr id="131" name="TextBox 130"/>
+          <p:cNvSpPr txBox="1"/>
+          <p:nvPr/>
+        </p:nvSpPr>
+        <p:spPr>
+          <a:xfrm>
+            <a:off x="685800" y="1446028"/>
             <a:ext cx="411480" cy="182880"/>
           </a:xfrm>
           <a:prstGeom prst="rect">
@@ -10994,20 +11204,20 @@
                 </a:solidFill>
                 <a:latin typeface="Calibri"/>
               </a:rPr>
-              <a:t>117</a:t>
-            </a:r>
-          </a:p>
-        </p:txBody>
-      </p:sp>
-      <p:sp>
-        <p:nvSpPr>
-          <p:cNvPr id="126" name="TextBox 125"/>
-          <p:cNvSpPr txBox="1"/>
-          <p:nvPr/>
-        </p:nvSpPr>
-        <p:spPr>
-          <a:xfrm>
-            <a:off x="685800" y="1398270"/>
+              <a:t>123</a:t>
+            </a:r>
+          </a:p>
+        </p:txBody>
+      </p:sp>
+      <p:sp>
+        <p:nvSpPr>
+          <p:cNvPr id="132" name="TextBox 131"/>
+          <p:cNvSpPr txBox="1"/>
+          <p:nvPr/>
+        </p:nvSpPr>
+        <p:spPr>
+          <a:xfrm>
+            <a:off x="685800" y="1433624"/>
             <a:ext cx="411480" cy="182880"/>
           </a:xfrm>
           <a:prstGeom prst="rect">
@@ -11029,20 +11239,20 @@
                 </a:solidFill>
                 <a:latin typeface="Calibri"/>
               </a:rPr>
-              <a:t>118</a:t>
-            </a:r>
-          </a:p>
-        </p:txBody>
-      </p:sp>
-      <p:sp>
-        <p:nvSpPr>
-          <p:cNvPr id="127" name="TextBox 126"/>
-          <p:cNvSpPr txBox="1"/>
-          <p:nvPr/>
-        </p:nvSpPr>
-        <p:spPr>
-          <a:xfrm>
-            <a:off x="685800" y="1384935"/>
+              <a:t>124</a:t>
+            </a:r>
+          </a:p>
+        </p:txBody>
+      </p:sp>
+      <p:sp>
+        <p:nvSpPr>
+          <p:cNvPr id="133" name="TextBox 132"/>
+          <p:cNvSpPr txBox="1"/>
+          <p:nvPr/>
+        </p:nvSpPr>
+        <p:spPr>
+          <a:xfrm>
+            <a:off x="685800" y="1421219"/>
             <a:ext cx="411480" cy="182880"/>
           </a:xfrm>
           <a:prstGeom prst="rect">
@@ -11064,14 +11274,119 @@
                 </a:solidFill>
                 <a:latin typeface="Calibri"/>
               </a:rPr>
-              <a:t>119</a:t>
-            </a:r>
-          </a:p>
-        </p:txBody>
-      </p:sp>
-      <p:sp>
-        <p:nvSpPr>
-          <p:cNvPr id="128" name="TextBox 127"/>
+              <a:t>125</a:t>
+            </a:r>
+          </a:p>
+        </p:txBody>
+      </p:sp>
+      <p:sp>
+        <p:nvSpPr>
+          <p:cNvPr id="134" name="TextBox 133"/>
+          <p:cNvSpPr txBox="1"/>
+          <p:nvPr/>
+        </p:nvSpPr>
+        <p:spPr>
+          <a:xfrm>
+            <a:off x="685800" y="1408814"/>
+            <a:ext cx="411480" cy="182880"/>
+          </a:xfrm>
+          <a:prstGeom prst="rect">
+            <a:avLst/>
+          </a:prstGeom>
+          <a:noFill/>
+        </p:spPr>
+        <p:txBody>
+          <a:bodyPr wrap="square" lIns="0" rIns="0" tIns="0" bIns="0">
+            <a:spAutoFit/>
+          </a:bodyPr>
+          <a:lstStyle/>
+          <a:p>
+            <a:pPr algn="r"/>
+            <a:r>
+              <a:rPr sz="900" b="0">
+                <a:solidFill>
+                  <a:srgbClr val="718096"/>
+                </a:solidFill>
+                <a:latin typeface="Calibri"/>
+              </a:rPr>
+              <a:t>126</a:t>
+            </a:r>
+          </a:p>
+        </p:txBody>
+      </p:sp>
+      <p:sp>
+        <p:nvSpPr>
+          <p:cNvPr id="135" name="TextBox 134"/>
+          <p:cNvSpPr txBox="1"/>
+          <p:nvPr/>
+        </p:nvSpPr>
+        <p:spPr>
+          <a:xfrm>
+            <a:off x="685800" y="1396410"/>
+            <a:ext cx="411480" cy="182880"/>
+          </a:xfrm>
+          <a:prstGeom prst="rect">
+            <a:avLst/>
+          </a:prstGeom>
+          <a:noFill/>
+        </p:spPr>
+        <p:txBody>
+          <a:bodyPr wrap="square" lIns="0" rIns="0" tIns="0" bIns="0">
+            <a:spAutoFit/>
+          </a:bodyPr>
+          <a:lstStyle/>
+          <a:p>
+            <a:pPr algn="r"/>
+            <a:r>
+              <a:rPr sz="900" b="0">
+                <a:solidFill>
+                  <a:srgbClr val="718096"/>
+                </a:solidFill>
+                <a:latin typeface="Calibri"/>
+              </a:rPr>
+              <a:t>127</a:t>
+            </a:r>
+          </a:p>
+        </p:txBody>
+      </p:sp>
+      <p:sp>
+        <p:nvSpPr>
+          <p:cNvPr id="136" name="TextBox 135"/>
+          <p:cNvSpPr txBox="1"/>
+          <p:nvPr/>
+        </p:nvSpPr>
+        <p:spPr>
+          <a:xfrm>
+            <a:off x="685800" y="1384005"/>
+            <a:ext cx="411480" cy="182880"/>
+          </a:xfrm>
+          <a:prstGeom prst="rect">
+            <a:avLst/>
+          </a:prstGeom>
+          <a:noFill/>
+        </p:spPr>
+        <p:txBody>
+          <a:bodyPr wrap="square" lIns="0" rIns="0" tIns="0" bIns="0">
+            <a:spAutoFit/>
+          </a:bodyPr>
+          <a:lstStyle/>
+          <a:p>
+            <a:pPr algn="r"/>
+            <a:r>
+              <a:rPr sz="900" b="0">
+                <a:solidFill>
+                  <a:srgbClr val="718096"/>
+                </a:solidFill>
+                <a:latin typeface="Calibri"/>
+              </a:rPr>
+              <a:t>128</a:t>
+            </a:r>
+          </a:p>
+        </p:txBody>
+      </p:sp>
+      <p:sp>
+        <p:nvSpPr>
+          <p:cNvPr id="137" name="TextBox 136"/>
           <p:cNvSpPr txBox="1"/>
           <p:nvPr/>
         </p:nvSpPr>
@@ -11099,21 +11414,21 @@
                 </a:solidFill>
                 <a:latin typeface="Calibri"/>
               </a:rPr>
-              <a:t>120</a:t>
-            </a:r>
-          </a:p>
-        </p:txBody>
-      </p:sp>
-      <p:sp>
-        <p:nvSpPr>
-          <p:cNvPr id="129" name="Rectangle 128"/>
+              <a:t>129</a:t>
+            </a:r>
+          </a:p>
+        </p:txBody>
+      </p:sp>
+      <p:sp>
+        <p:nvSpPr>
+          <p:cNvPr id="138" name="Rectangle 137"/>
           <p:cNvSpPr/>
           <p:nvPr/>
         </p:nvSpPr>
         <p:spPr>
           <a:xfrm>
-            <a:off x="1505560" y="3023235"/>
-            <a:ext cx="774496" cy="40005"/>
+            <a:off x="1505560" y="3026027"/>
+            <a:ext cx="774496" cy="37213"/>
           </a:xfrm>
           <a:prstGeom prst="rect">
             <a:avLst/>
@@ -11149,7 +11464,7 @@
       </p:sp>
       <p:sp>
         <p:nvSpPr>
-          <p:cNvPr id="130" name="TextBox 129"/>
+          <p:cNvPr id="139" name="TextBox 138"/>
           <p:cNvSpPr txBox="1"/>
           <p:nvPr/>
         </p:nvSpPr>
@@ -11184,7 +11499,7 @@
       </p:sp>
       <p:sp>
         <p:nvSpPr>
-          <p:cNvPr id="131" name="TextBox 130"/>
+          <p:cNvPr id="140" name="TextBox 139"/>
           <p:cNvSpPr txBox="1"/>
           <p:nvPr/>
         </p:nvSpPr>
@@ -11219,14 +11534,14 @@
       </p:sp>
       <p:sp>
         <p:nvSpPr>
-          <p:cNvPr id="132" name="Rectangle 131"/>
+          <p:cNvPr id="141" name="Rectangle 140"/>
           <p:cNvSpPr/>
           <p:nvPr/>
         </p:nvSpPr>
         <p:spPr>
           <a:xfrm>
-            <a:off x="2913736" y="2903220"/>
-            <a:ext cx="774496" cy="160020"/>
+            <a:off x="2913736" y="2852361"/>
+            <a:ext cx="774496" cy="210879"/>
           </a:xfrm>
           <a:prstGeom prst="rect">
             <a:avLst/>
@@ -11262,14 +11577,14 @@
       </p:sp>
       <p:sp>
         <p:nvSpPr>
-          <p:cNvPr id="133" name="Rectangle 132"/>
+          <p:cNvPr id="142" name="Rectangle 141"/>
           <p:cNvSpPr/>
           <p:nvPr/>
         </p:nvSpPr>
         <p:spPr>
           <a:xfrm>
-            <a:off x="2913736" y="2849880"/>
-            <a:ext cx="774496" cy="53340"/>
+            <a:off x="2913736" y="2790338"/>
+            <a:ext cx="774496" cy="62023"/>
           </a:xfrm>
           <a:prstGeom prst="rect">
             <a:avLst/>
@@ -11305,7 +11620,7 @@
       </p:sp>
       <p:sp>
         <p:nvSpPr>
-          <p:cNvPr id="134" name="TextBox 133"/>
+          <p:cNvPr id="143" name="TextBox 142"/>
           <p:cNvSpPr txBox="1"/>
           <p:nvPr/>
         </p:nvSpPr>
@@ -11340,7 +11655,7 @@
       </p:sp>
       <p:sp>
         <p:nvSpPr>
-          <p:cNvPr id="135" name="TextBox 134"/>
+          <p:cNvPr id="144" name="TextBox 143"/>
           <p:cNvSpPr txBox="1"/>
           <p:nvPr/>
         </p:nvSpPr>
@@ -11368,21 +11683,21 @@
                 </a:solidFill>
                 <a:latin typeface="Calibri"/>
               </a:rPr>
-              <a:t>4 / 16</a:t>
-            </a:r>
-          </a:p>
-        </p:txBody>
-      </p:sp>
-      <p:sp>
-        <p:nvSpPr>
-          <p:cNvPr id="136" name="Rectangle 135"/>
+              <a:t>5 / 22</a:t>
+            </a:r>
+          </a:p>
+        </p:txBody>
+      </p:sp>
+      <p:sp>
+        <p:nvSpPr>
+          <p:cNvPr id="145" name="Rectangle 144"/>
           <p:cNvSpPr/>
           <p:nvPr/>
         </p:nvSpPr>
         <p:spPr>
           <a:xfrm>
-            <a:off x="4321912" y="2649855"/>
-            <a:ext cx="774496" cy="413385"/>
+            <a:off x="4321912" y="2579459"/>
+            <a:ext cx="774496" cy="483781"/>
           </a:xfrm>
           <a:prstGeom prst="rect">
             <a:avLst/>
@@ -11418,14 +11733,14 @@
       </p:sp>
       <p:sp>
         <p:nvSpPr>
-          <p:cNvPr id="137" name="Rectangle 136"/>
+          <p:cNvPr id="146" name="Rectangle 145"/>
           <p:cNvSpPr/>
           <p:nvPr/>
         </p:nvSpPr>
         <p:spPr>
           <a:xfrm>
-            <a:off x="4321912" y="1463040"/>
-            <a:ext cx="774496" cy="1186815"/>
+            <a:off x="4321912" y="1463041"/>
+            <a:ext cx="774496" cy="1116418"/>
           </a:xfrm>
           <a:prstGeom prst="rect">
             <a:avLst/>
@@ -11461,7 +11776,7 @@
       </p:sp>
       <p:sp>
         <p:nvSpPr>
-          <p:cNvPr id="138" name="TextBox 137"/>
+          <p:cNvPr id="147" name="TextBox 146"/>
           <p:cNvSpPr txBox="1"/>
           <p:nvPr/>
         </p:nvSpPr>
@@ -11496,7 +11811,7 @@
       </p:sp>
       <p:sp>
         <p:nvSpPr>
-          <p:cNvPr id="139" name="TextBox 138"/>
+          <p:cNvPr id="148" name="TextBox 147"/>
           <p:cNvSpPr txBox="1"/>
           <p:nvPr/>
         </p:nvSpPr>
@@ -11524,21 +11839,21 @@
                 </a:solidFill>
                 <a:latin typeface="Calibri"/>
               </a:rPr>
-              <a:t>89 / 120</a:t>
-            </a:r>
-          </a:p>
-        </p:txBody>
-      </p:sp>
-      <p:sp>
-        <p:nvSpPr>
-          <p:cNvPr id="140" name="Rectangle 139"/>
+              <a:t>90 / 129</a:t>
+            </a:r>
+          </a:p>
+        </p:txBody>
+      </p:sp>
+      <p:sp>
+        <p:nvSpPr>
+          <p:cNvPr id="149" name="Rectangle 148"/>
           <p:cNvSpPr/>
           <p:nvPr/>
         </p:nvSpPr>
         <p:spPr>
           <a:xfrm>
-            <a:off x="5730088" y="3023235"/>
-            <a:ext cx="774496" cy="40005"/>
+            <a:off x="5730088" y="3026027"/>
+            <a:ext cx="774496" cy="37213"/>
           </a:xfrm>
           <a:prstGeom prst="rect">
             <a:avLst/>
@@ -11574,7 +11889,7 @@
       </p:sp>
       <p:sp>
         <p:nvSpPr>
-          <p:cNvPr id="141" name="TextBox 140"/>
+          <p:cNvPr id="150" name="TextBox 149"/>
           <p:cNvSpPr txBox="1"/>
           <p:nvPr/>
         </p:nvSpPr>
@@ -11609,7 +11924,7 @@
       </p:sp>
       <p:sp>
         <p:nvSpPr>
-          <p:cNvPr id="142" name="TextBox 141"/>
+          <p:cNvPr id="151" name="TextBox 150"/>
           <p:cNvSpPr txBox="1"/>
           <p:nvPr/>
         </p:nvSpPr>
@@ -11644,14 +11959,14 @@
       </p:sp>
       <p:sp>
         <p:nvSpPr>
-          <p:cNvPr id="143" name="Rectangle 142"/>
+          <p:cNvPr id="152" name="Rectangle 151"/>
           <p:cNvSpPr/>
           <p:nvPr/>
         </p:nvSpPr>
         <p:spPr>
           <a:xfrm>
-            <a:off x="7138264" y="3036570"/>
-            <a:ext cx="774496" cy="26670"/>
+            <a:off x="7138264" y="3038431"/>
+            <a:ext cx="774496" cy="24809"/>
           </a:xfrm>
           <a:prstGeom prst="rect">
             <a:avLst/>
@@ -11687,7 +12002,7 @@
       </p:sp>
       <p:sp>
         <p:nvSpPr>
-          <p:cNvPr id="144" name="TextBox 143"/>
+          <p:cNvPr id="153" name="TextBox 152"/>
           <p:cNvSpPr txBox="1"/>
           <p:nvPr/>
         </p:nvSpPr>
@@ -11722,7 +12037,7 @@
       </p:sp>
       <p:sp>
         <p:nvSpPr>
-          <p:cNvPr id="145" name="TextBox 144"/>
+          <p:cNvPr id="154" name="TextBox 153"/>
           <p:cNvSpPr txBox="1"/>
           <p:nvPr/>
         </p:nvSpPr>
@@ -11757,7 +12072,7 @@
       </p:sp>
       <p:sp>
         <p:nvSpPr>
-          <p:cNvPr id="146" name="Rectangle 145"/>
+          <p:cNvPr id="155" name="Rectangle 154"/>
           <p:cNvSpPr/>
           <p:nvPr/>
         </p:nvSpPr>
@@ -11800,7 +12115,7 @@
       </p:sp>
       <p:sp>
         <p:nvSpPr>
-          <p:cNvPr id="147" name="TextBox 146"/>
+          <p:cNvPr id="156" name="TextBox 155"/>
           <p:cNvSpPr txBox="1"/>
           <p:nvPr/>
         </p:nvSpPr>
@@ -11835,7 +12150,7 @@
       </p:sp>
       <p:sp>
         <p:nvSpPr>
-          <p:cNvPr id="148" name="Rectangle 147"/>
+          <p:cNvPr id="157" name="Rectangle 156"/>
           <p:cNvSpPr/>
           <p:nvPr/>
         </p:nvSpPr>
@@ -11878,7 +12193,7 @@
       </p:sp>
       <p:sp>
         <p:nvSpPr>
-          <p:cNvPr id="149" name="TextBox 148"/>
+          <p:cNvPr id="158" name="TextBox 157"/>
           <p:cNvSpPr txBox="1"/>
           <p:nvPr/>
         </p:nvSpPr>
@@ -11913,7 +12228,7 @@
       </p:sp>
       <p:sp>
         <p:nvSpPr>
-          <p:cNvPr id="150" name="Rectangle 149"/>
+          <p:cNvPr id="159" name="Rectangle 158"/>
           <p:cNvSpPr/>
           <p:nvPr/>
         </p:nvSpPr>
@@ -11956,7 +12271,7 @@
       </p:sp>
       <p:sp>
         <p:nvSpPr>
-          <p:cNvPr id="151" name="TextBox 150"/>
+          <p:cNvPr id="160" name="TextBox 159"/>
           <p:cNvSpPr txBox="1"/>
           <p:nvPr/>
         </p:nvSpPr>
@@ -11991,7 +12306,7 @@
       </p:sp>
       <p:sp>
         <p:nvSpPr>
-          <p:cNvPr id="152" name="TextBox 151"/>
+          <p:cNvPr id="161" name="TextBox 160"/>
           <p:cNvSpPr txBox="1"/>
           <p:nvPr/>
         </p:nvSpPr>

</xml_diff>